<commit_message>
Add dedicated System Architecture slide taken directly from README specification
</commit_message>
<xml_diff>
--- a/pitch-deck/PRAHAR-Pitch-Deck.pptx
+++ b/pitch-deck/PRAHAR-Pitch-Deck.pptx
@@ -3521,7 +3521,7 @@
     <p:bg>
       <p:bgPr>
         <a:solidFill>
-          <a:srgbClr val="0A192F"/>
+          <a:srgbClr val="F8FAFC"/>
         </a:solidFill>
         <a:effectLst/>
       </p:bgPr>
@@ -3593,68 +3593,44 @@
           <a:noFill/>
         </p:spPr>
         <p:txBody>
-          <a:bodyPr wrap="none">
+          <a:bodyPr wrap="square" lIns="0" tIns="0" rIns="0" bIns="0">
             <a:spAutoFit/>
           </a:bodyPr>
           <a:lstStyle/>
           <a:p>
             <a:pPr>
-              <a:defRPr sz="2200" b="1">
-                <a:solidFill>
-                  <a:srgbClr val="FFFFFF"/>
-                </a:solidFill>
-              </a:defRPr>
-            </a:pPr>
-            <a:r>
-              <a:t>Enterprise System Architecture &amp; Immediate Readiness</a:t>
-            </a:r>
-          </a:p>
-        </p:txBody>
-      </p:sp>
-      <p:pic>
-        <p:nvPicPr>
-          <p:cNvPr id="4" name="Picture 3" descr="architecture_pipeline.png"/>
-          <p:cNvPicPr>
-            <a:picLocks noChangeAspect="1"/>
-          </p:cNvPicPr>
-          <p:nvPr/>
-        </p:nvPicPr>
-        <p:blipFill>
-          <a:blip r:embed="rId2"/>
-          <a:stretch>
-            <a:fillRect/>
-          </a:stretch>
-        </p:blipFill>
-        <p:spPr>
-          <a:xfrm>
-            <a:off x="731520" y="1097280"/>
-            <a:ext cx="10698480" cy="3291840"/>
-          </a:xfrm>
-          <a:prstGeom prst="rect">
-            <a:avLst/>
-          </a:prstGeom>
-        </p:spPr>
-      </p:pic>
-      <p:sp>
-        <p:nvSpPr>
-          <p:cNvPr id="5" name="Rounded Rectangle 4"/>
+              <a:defRPr sz="2400" b="1">
+                <a:solidFill>
+                  <a:srgbClr val="0F172A"/>
+                </a:solidFill>
+              </a:defRPr>
+            </a:pPr>
+            <a:r>
+              <a:t>System Architecture</a:t>
+            </a:r>
+          </a:p>
+        </p:txBody>
+      </p:sp>
+      <p:sp>
+        <p:nvSpPr>
+          <p:cNvPr id="4" name="Rounded Rectangle 3"/>
           <p:cNvSpPr/>
           <p:nvPr/>
         </p:nvSpPr>
         <p:spPr>
           <a:xfrm>
-            <a:off x="731520" y="4663440"/>
-            <a:ext cx="10698480" cy="1645920"/>
+            <a:off x="731520" y="1188720"/>
+            <a:ext cx="2514600" cy="4114800"/>
           </a:xfrm>
           <a:prstGeom prst="roundRect">
             <a:avLst/>
           </a:prstGeom>
           <a:solidFill>
-            <a:srgbClr val="0F213C"/>
+            <a:srgbClr val="FFFFFF"/>
           </a:solidFill>
           <a:ln>
             <a:solidFill>
-              <a:srgbClr val="00836C"/>
+              <a:srgbClr val="E2E8F0"/>
             </a:solidFill>
           </a:ln>
         </p:spPr>
@@ -3673,48 +3649,777 @@
           </a:fontRef>
         </p:style>
         <p:txBody>
-          <a:bodyPr rtlCol="0" anchor="ctr" wrap="square" lIns="228600" tIns="228600" rIns="228600" bIns="228600"/>
-          <a:lstStyle/>
-          <a:p>
-            <a:pPr algn="ctr">
+          <a:bodyPr rtlCol="0" anchor="ctr"/>
+          <a:lstStyle/>
+          <a:p>
+            <a:pPr algn="ctr"/>
+          </a:p>
+        </p:txBody>
+      </p:sp>
+      <p:sp>
+        <p:nvSpPr>
+          <p:cNvPr id="5" name="Rectangle 4"/>
+          <p:cNvSpPr/>
+          <p:nvPr/>
+        </p:nvSpPr>
+        <p:spPr>
+          <a:xfrm>
+            <a:off x="914400" y="1371600"/>
+            <a:ext cx="457200" cy="73152"/>
+          </a:xfrm>
+          <a:prstGeom prst="rect">
+            <a:avLst/>
+          </a:prstGeom>
+          <a:solidFill>
+            <a:srgbClr val="1E3A5F"/>
+          </a:solidFill>
+          <a:ln>
+            <a:noFill/>
+          </a:ln>
+        </p:spPr>
+        <p:style>
+          <a:lnRef idx="1">
+            <a:schemeClr val="accent1"/>
+          </a:lnRef>
+          <a:fillRef idx="3">
+            <a:schemeClr val="accent1"/>
+          </a:fillRef>
+          <a:effectRef idx="2">
+            <a:schemeClr val="accent1"/>
+          </a:effectRef>
+          <a:fontRef idx="minor">
+            <a:schemeClr val="lt1"/>
+          </a:fontRef>
+        </p:style>
+        <p:txBody>
+          <a:bodyPr rtlCol="0" anchor="ctr"/>
+          <a:lstStyle/>
+          <a:p>
+            <a:pPr algn="ctr"/>
+          </a:p>
+        </p:txBody>
+      </p:sp>
+      <p:sp>
+        <p:nvSpPr>
+          <p:cNvPr id="6" name="TextBox 5"/>
+          <p:cNvSpPr txBox="1"/>
+          <p:nvPr/>
+        </p:nvSpPr>
+        <p:spPr>
+          <a:xfrm>
+            <a:off x="914400" y="1554480"/>
+            <a:ext cx="2148840" cy="3566160"/>
+          </a:xfrm>
+          <a:prstGeom prst="rect">
+            <a:avLst/>
+          </a:prstGeom>
+          <a:noFill/>
+        </p:spPr>
+        <p:txBody>
+          <a:bodyPr wrap="square">
+            <a:spAutoFit/>
+          </a:bodyPr>
+          <a:lstStyle/>
+          <a:p>
+            <a:pPr>
+              <a:spcAft>
+                <a:spcPts val="1400"/>
+              </a:spcAft>
+              <a:defRPr sz="1300" b="1">
+                <a:solidFill>
+                  <a:srgbClr val="0F172A"/>
+                </a:solidFill>
+              </a:defRPr>
+            </a:pPr>
+            <a:r>
+              <a:t>1. External Feeds &amp; Telemetry</a:t>
+            </a:r>
+          </a:p>
+          <a:p>
+            <a:pPr>
               <a:spcAft>
                 <a:spcPts val="600"/>
               </a:spcAft>
-              <a:defRPr sz="2200" b="1">
-                <a:solidFill>
-                  <a:srgbClr val="FFFFFF"/>
-                </a:solidFill>
-              </a:defRPr>
-            </a:pPr>
-            <a:r>
-              <a:t>Anticipate. Protect. Empower Coastal Resilience.</a:t>
-            </a:r>
-          </a:p>
+              <a:defRPr sz="1000">
+                <a:solidFill>
+                  <a:srgbClr val="64748B"/>
+                </a:solidFill>
+              </a:defRPr>
+            </a:pPr>
+            <a:r>
+              <a:t>• IMD / JTWC: Real-time cyclone tracks &amp; cones</a:t>
+            </a:r>
+          </a:p>
+          <a:p>
+            <a:pPr>
+              <a:spcAft>
+                <a:spcPts val="600"/>
+              </a:spcAft>
+              <a:defRPr sz="1000">
+                <a:solidFill>
+                  <a:srgbClr val="64748B"/>
+                </a:solidFill>
+              </a:defRPr>
+            </a:pPr>
+            <a:r>
+              <a:t>• Google Earth Engine: Copernicus DEM 30m, Sentinel-1 SAR</a:t>
+            </a:r>
+          </a:p>
+          <a:p>
+            <a:pPr>
+              <a:spcAft>
+                <a:spcPts val="600"/>
+              </a:spcAft>
+              <a:defRPr sz="1000">
+                <a:solidFill>
+                  <a:srgbClr val="64748B"/>
+                </a:solidFill>
+              </a:defRPr>
+            </a:pPr>
+            <a:r>
+              <a:t>• OSM Overpass: Hospitals, Sub-stations, Arterial Bridges</a:t>
+            </a:r>
+          </a:p>
+          <a:p>
+            <a:pPr>
+              <a:spcAft>
+                <a:spcPts val="600"/>
+              </a:spcAft>
+              <a:defRPr sz="1000">
+                <a:solidFill>
+                  <a:srgbClr val="64748B"/>
+                </a:solidFill>
+              </a:defRPr>
+            </a:pPr>
+            <a:r>
+              <a:t>• INCOIS / NOAA: Coastal Tide Gauges &amp; Bathymetry</a:t>
+            </a:r>
+          </a:p>
+        </p:txBody>
+      </p:sp>
+      <p:sp>
+        <p:nvSpPr>
+          <p:cNvPr id="7" name="Rounded Rectangle 6"/>
+          <p:cNvSpPr/>
+          <p:nvPr/>
+        </p:nvSpPr>
+        <p:spPr>
+          <a:xfrm>
+            <a:off x="3456432" y="1188720"/>
+            <a:ext cx="2514600" cy="4114800"/>
+          </a:xfrm>
+          <a:prstGeom prst="roundRect">
+            <a:avLst/>
+          </a:prstGeom>
+          <a:solidFill>
+            <a:srgbClr val="FFFFFF"/>
+          </a:solidFill>
+          <a:ln>
+            <a:solidFill>
+              <a:srgbClr val="E2E8F0"/>
+            </a:solidFill>
+          </a:ln>
+        </p:spPr>
+        <p:style>
+          <a:lnRef idx="1">
+            <a:schemeClr val="accent1"/>
+          </a:lnRef>
+          <a:fillRef idx="3">
+            <a:schemeClr val="accent1"/>
+          </a:fillRef>
+          <a:effectRef idx="2">
+            <a:schemeClr val="accent1"/>
+          </a:effectRef>
+          <a:fontRef idx="minor">
+            <a:schemeClr val="lt1"/>
+          </a:fontRef>
+        </p:style>
+        <p:txBody>
+          <a:bodyPr rtlCol="0" anchor="ctr"/>
+          <a:lstStyle/>
+          <a:p>
+            <a:pPr algn="ctr"/>
+          </a:p>
+        </p:txBody>
+      </p:sp>
+      <p:sp>
+        <p:nvSpPr>
+          <p:cNvPr id="8" name="Rectangle 7"/>
+          <p:cNvSpPr/>
+          <p:nvPr/>
+        </p:nvSpPr>
+        <p:spPr>
+          <a:xfrm>
+            <a:off x="3639312" y="1371600"/>
+            <a:ext cx="457200" cy="73152"/>
+          </a:xfrm>
+          <a:prstGeom prst="rect">
+            <a:avLst/>
+          </a:prstGeom>
+          <a:solidFill>
+            <a:srgbClr val="00836C"/>
+          </a:solidFill>
+          <a:ln>
+            <a:noFill/>
+          </a:ln>
+        </p:spPr>
+        <p:style>
+          <a:lnRef idx="1">
+            <a:schemeClr val="accent1"/>
+          </a:lnRef>
+          <a:fillRef idx="3">
+            <a:schemeClr val="accent1"/>
+          </a:fillRef>
+          <a:effectRef idx="2">
+            <a:schemeClr val="accent1"/>
+          </a:effectRef>
+          <a:fontRef idx="minor">
+            <a:schemeClr val="lt1"/>
+          </a:fontRef>
+        </p:style>
+        <p:txBody>
+          <a:bodyPr rtlCol="0" anchor="ctr"/>
+          <a:lstStyle/>
+          <a:p>
+            <a:pPr algn="ctr"/>
+          </a:p>
+        </p:txBody>
+      </p:sp>
+      <p:sp>
+        <p:nvSpPr>
+          <p:cNvPr id="9" name="TextBox 8"/>
+          <p:cNvSpPr txBox="1"/>
+          <p:nvPr/>
+        </p:nvSpPr>
+        <p:spPr>
+          <a:xfrm>
+            <a:off x="3639312" y="1554480"/>
+            <a:ext cx="2148840" cy="3566160"/>
+          </a:xfrm>
+          <a:prstGeom prst="rect">
+            <a:avLst/>
+          </a:prstGeom>
+          <a:noFill/>
+        </p:spPr>
+        <p:txBody>
+          <a:bodyPr wrap="square">
+            <a:spAutoFit/>
+          </a:bodyPr>
+          <a:lstStyle/>
+          <a:p>
+            <a:pPr>
+              <a:spcAft>
+                <a:spcPts val="1400"/>
+              </a:spcAft>
+              <a:defRPr sz="1300" b="1">
+                <a:solidFill>
+                  <a:srgbClr val="0F172A"/>
+                </a:solidFill>
+              </a:defRPr>
+            </a:pPr>
+            <a:r>
+              <a:t>2. Ingestion Microservice (:8001)</a:t>
+            </a:r>
+          </a:p>
+          <a:p>
+            <a:pPr>
+              <a:spcAft>
+                <a:spcPts val="600"/>
+              </a:spcAft>
+              <a:defRPr sz="1000">
+                <a:solidFill>
+                  <a:srgbClr val="64748B"/>
+                </a:solidFill>
+              </a:defRPr>
+            </a:pPr>
+            <a:r>
+              <a:t>• Async Ingestion Worker &amp; Poller Daemon</a:t>
+            </a:r>
+          </a:p>
+          <a:p>
+            <a:pPr>
+              <a:spcAft>
+                <a:spcPts val="600"/>
+              </a:spcAft>
+              <a:defRPr sz="1000">
+                <a:solidFill>
+                  <a:srgbClr val="64748B"/>
+                </a:solidFill>
+              </a:defRPr>
+            </a:pPr>
+            <a:r>
+              <a:t>• Track Normalizer &amp; Cone of Uncertainty Generator</a:t>
+            </a:r>
+          </a:p>
+          <a:p>
+            <a:pPr>
+              <a:spcAft>
+                <a:spcPts val="600"/>
+              </a:spcAft>
+              <a:defRPr sz="1000">
+                <a:solidFill>
+                  <a:srgbClr val="64748B"/>
+                </a:solidFill>
+              </a:defRPr>
+            </a:pPr>
+            <a:r>
+              <a:t>• GEE Elevation &amp; Bathymetric Sampler</a:t>
+            </a:r>
+          </a:p>
+          <a:p>
+            <a:pPr>
+              <a:spcAft>
+                <a:spcPts val="600"/>
+              </a:spcAft>
+              <a:defRPr sz="1000">
+                <a:solidFill>
+                  <a:srgbClr val="64748B"/>
+                </a:solidFill>
+              </a:defRPr>
+            </a:pPr>
+            <a:r>
+              <a:t>• OSM Infrastructure Feature Extractor</a:t>
+            </a:r>
+          </a:p>
+        </p:txBody>
+      </p:sp>
+      <p:sp>
+        <p:nvSpPr>
+          <p:cNvPr id="10" name="Rounded Rectangle 9"/>
+          <p:cNvSpPr/>
+          <p:nvPr/>
+        </p:nvSpPr>
+        <p:spPr>
+          <a:xfrm>
+            <a:off x="6181344" y="1188720"/>
+            <a:ext cx="2514600" cy="4114800"/>
+          </a:xfrm>
+          <a:prstGeom prst="roundRect">
+            <a:avLst/>
+          </a:prstGeom>
+          <a:solidFill>
+            <a:srgbClr val="FFFFFF"/>
+          </a:solidFill>
+          <a:ln>
+            <a:solidFill>
+              <a:srgbClr val="E2E8F0"/>
+            </a:solidFill>
+          </a:ln>
+        </p:spPr>
+        <p:style>
+          <a:lnRef idx="1">
+            <a:schemeClr val="accent1"/>
+          </a:lnRef>
+          <a:fillRef idx="3">
+            <a:schemeClr val="accent1"/>
+          </a:fillRef>
+          <a:effectRef idx="2">
+            <a:schemeClr val="accent1"/>
+          </a:effectRef>
+          <a:fontRef idx="minor">
+            <a:schemeClr val="lt1"/>
+          </a:fontRef>
+        </p:style>
+        <p:txBody>
+          <a:bodyPr rtlCol="0" anchor="ctr"/>
+          <a:lstStyle/>
+          <a:p>
+            <a:pPr algn="ctr"/>
+          </a:p>
+        </p:txBody>
+      </p:sp>
+      <p:sp>
+        <p:nvSpPr>
+          <p:cNvPr id="11" name="Rectangle 10"/>
+          <p:cNvSpPr/>
+          <p:nvPr/>
+        </p:nvSpPr>
+        <p:spPr>
+          <a:xfrm>
+            <a:off x="6364224" y="1371600"/>
+            <a:ext cx="457200" cy="73152"/>
+          </a:xfrm>
+          <a:prstGeom prst="rect">
+            <a:avLst/>
+          </a:prstGeom>
+          <a:solidFill>
+            <a:srgbClr val="F58220"/>
+          </a:solidFill>
+          <a:ln>
+            <a:noFill/>
+          </a:ln>
+        </p:spPr>
+        <p:style>
+          <a:lnRef idx="1">
+            <a:schemeClr val="accent1"/>
+          </a:lnRef>
+          <a:fillRef idx="3">
+            <a:schemeClr val="accent1"/>
+          </a:fillRef>
+          <a:effectRef idx="2">
+            <a:schemeClr val="accent1"/>
+          </a:effectRef>
+          <a:fontRef idx="minor">
+            <a:schemeClr val="lt1"/>
+          </a:fontRef>
+        </p:style>
+        <p:txBody>
+          <a:bodyPr rtlCol="0" anchor="ctr"/>
+          <a:lstStyle/>
+          <a:p>
+            <a:pPr algn="ctr"/>
+          </a:p>
+        </p:txBody>
+      </p:sp>
+      <p:sp>
+        <p:nvSpPr>
+          <p:cNvPr id="12" name="TextBox 11"/>
+          <p:cNvSpPr txBox="1"/>
+          <p:nvPr/>
+        </p:nvSpPr>
+        <p:spPr>
+          <a:xfrm>
+            <a:off x="6364224" y="1554480"/>
+            <a:ext cx="2148840" cy="3566160"/>
+          </a:xfrm>
+          <a:prstGeom prst="rect">
+            <a:avLst/>
+          </a:prstGeom>
+          <a:noFill/>
+        </p:spPr>
+        <p:txBody>
+          <a:bodyPr wrap="square">
+            <a:spAutoFit/>
+          </a:bodyPr>
+          <a:lstStyle/>
+          <a:p>
+            <a:pPr>
+              <a:spcAft>
+                <a:spcPts val="1400"/>
+              </a:spcAft>
+              <a:defRPr sz="1300" b="1">
+                <a:solidFill>
+                  <a:srgbClr val="0F172A"/>
+                </a:solidFill>
+              </a:defRPr>
+            </a:pPr>
+            <a:r>
+              <a:t>3. Core Simulation Engine (:8010)</a:t>
+            </a:r>
+          </a:p>
+          <a:p>
+            <a:pPr>
+              <a:spcAft>
+                <a:spcPts val="600"/>
+              </a:spcAft>
+              <a:defRPr sz="1000">
+                <a:solidFill>
+                  <a:srgbClr val="64748B"/>
+                </a:solidFill>
+              </a:defRPr>
+            </a:pPr>
+            <a:r>
+              <a:t>• FastAPI 0.111 Application Core</a:t>
+            </a:r>
+          </a:p>
+          <a:p>
+            <a:pPr>
+              <a:spcAft>
+                <a:spcPts val="600"/>
+              </a:spcAft>
+              <a:defRPr sz="1000">
+                <a:solidFill>
+                  <a:srgbClr val="64748B"/>
+                </a:solidFill>
+              </a:defRPr>
+            </a:pPr>
+            <a:r>
+              <a:t>• SLOSH Storm Surge &amp; Inundation Model</a:t>
+            </a:r>
+          </a:p>
+          <a:p>
+            <a:pPr>
+              <a:spcAft>
+                <a:spcPts val="600"/>
+              </a:spcAft>
+              <a:defRPr sz="1000">
+                <a:solidFill>
+                  <a:srgbClr val="64748B"/>
+                </a:solidFill>
+              </a:defRPr>
+            </a:pPr>
+            <a:r>
+              <a:t>• Compound River-Surge Backwater Engine</a:t>
+            </a:r>
+          </a:p>
+          <a:p>
+            <a:pPr>
+              <a:spcAft>
+                <a:spcPts val="600"/>
+              </a:spcAft>
+              <a:defRPr sz="1000">
+                <a:solidFill>
+                  <a:srgbClr val="64748B"/>
+                </a:solidFill>
+              </a:defRPr>
+            </a:pPr>
+            <a:r>
+              <a:t>• NetworkX Infrastructure Severance Graph</a:t>
+            </a:r>
+          </a:p>
+          <a:p>
+            <a:pPr>
+              <a:spcAft>
+                <a:spcPts val="600"/>
+              </a:spcAft>
+              <a:defRPr sz="1000">
+                <a:solidFill>
+                  <a:srgbClr val="64748B"/>
+                </a:solidFill>
+              </a:defRPr>
+            </a:pPr>
+            <a:r>
+              <a:t>• Parametric Escrow Controller &amp; Gemini AI</a:t>
+            </a:r>
+          </a:p>
+        </p:txBody>
+      </p:sp>
+      <p:sp>
+        <p:nvSpPr>
+          <p:cNvPr id="13" name="Rounded Rectangle 12"/>
+          <p:cNvSpPr/>
+          <p:nvPr/>
+        </p:nvSpPr>
+        <p:spPr>
+          <a:xfrm>
+            <a:off x="8906256" y="1188720"/>
+            <a:ext cx="2514600" cy="4114800"/>
+          </a:xfrm>
+          <a:prstGeom prst="roundRect">
+            <a:avLst/>
+          </a:prstGeom>
+          <a:solidFill>
+            <a:srgbClr val="FFFFFF"/>
+          </a:solidFill>
+          <a:ln>
+            <a:solidFill>
+              <a:srgbClr val="E2E8F0"/>
+            </a:solidFill>
+          </a:ln>
+        </p:spPr>
+        <p:style>
+          <a:lnRef idx="1">
+            <a:schemeClr val="accent1"/>
+          </a:lnRef>
+          <a:fillRef idx="3">
+            <a:schemeClr val="accent1"/>
+          </a:fillRef>
+          <a:effectRef idx="2">
+            <a:schemeClr val="accent1"/>
+          </a:effectRef>
+          <a:fontRef idx="minor">
+            <a:schemeClr val="lt1"/>
+          </a:fontRef>
+        </p:style>
+        <p:txBody>
+          <a:bodyPr rtlCol="0" anchor="ctr"/>
+          <a:lstStyle/>
+          <a:p>
+            <a:pPr algn="ctr"/>
+          </a:p>
+        </p:txBody>
+      </p:sp>
+      <p:sp>
+        <p:nvSpPr>
+          <p:cNvPr id="14" name="Rectangle 13"/>
+          <p:cNvSpPr/>
+          <p:nvPr/>
+        </p:nvSpPr>
+        <p:spPr>
+          <a:xfrm>
+            <a:off x="9089136" y="1371600"/>
+            <a:ext cx="457200" cy="73152"/>
+          </a:xfrm>
+          <a:prstGeom prst="rect">
+            <a:avLst/>
+          </a:prstGeom>
+          <a:solidFill>
+            <a:srgbClr val="D03B3B"/>
+          </a:solidFill>
+          <a:ln>
+            <a:noFill/>
+          </a:ln>
+        </p:spPr>
+        <p:style>
+          <a:lnRef idx="1">
+            <a:schemeClr val="accent1"/>
+          </a:lnRef>
+          <a:fillRef idx="3">
+            <a:schemeClr val="accent1"/>
+          </a:fillRef>
+          <a:effectRef idx="2">
+            <a:schemeClr val="accent1"/>
+          </a:effectRef>
+          <a:fontRef idx="minor">
+            <a:schemeClr val="lt1"/>
+          </a:fontRef>
+        </p:style>
+        <p:txBody>
+          <a:bodyPr rtlCol="0" anchor="ctr"/>
+          <a:lstStyle/>
+          <a:p>
+            <a:pPr algn="ctr"/>
+          </a:p>
+        </p:txBody>
+      </p:sp>
+      <p:sp>
+        <p:nvSpPr>
+          <p:cNvPr id="15" name="TextBox 14"/>
+          <p:cNvSpPr txBox="1"/>
+          <p:nvPr/>
+        </p:nvSpPr>
+        <p:spPr>
+          <a:xfrm>
+            <a:off x="9089136" y="1554480"/>
+            <a:ext cx="2148840" cy="3566160"/>
+          </a:xfrm>
+          <a:prstGeom prst="rect">
+            <a:avLst/>
+          </a:prstGeom>
+          <a:noFill/>
+        </p:spPr>
+        <p:txBody>
+          <a:bodyPr wrap="square">
+            <a:spAutoFit/>
+          </a:bodyPr>
+          <a:lstStyle/>
+          <a:p>
+            <a:pPr>
+              <a:spcAft>
+                <a:spcPts val="1400"/>
+              </a:spcAft>
+              <a:defRPr sz="1300" b="1">
+                <a:solidFill>
+                  <a:srgbClr val="0F172A"/>
+                </a:solidFill>
+              </a:defRPr>
+            </a:pPr>
+            <a:r>
+              <a:t>4. Storage &amp; Presentation Tier</a:t>
+            </a:r>
+          </a:p>
+          <a:p>
+            <a:pPr>
+              <a:spcAft>
+                <a:spcPts val="600"/>
+              </a:spcAft>
+              <a:defRPr sz="1000">
+                <a:solidFill>
+                  <a:srgbClr val="64748B"/>
+                </a:solidFill>
+              </a:defRPr>
+            </a:pPr>
+            <a:r>
+              <a:t>• PostgreSQL / PostGIS Spatial DB &amp; Redis Cache</a:t>
+            </a:r>
+          </a:p>
+          <a:p>
+            <a:pPr>
+              <a:spcAft>
+                <a:spcPts val="600"/>
+              </a:spcAft>
+              <a:defRPr sz="1000">
+                <a:solidFill>
+                  <a:srgbClr val="64748B"/>
+                </a:solidFill>
+              </a:defRPr>
+            </a:pPr>
+            <a:r>
+              <a:t>• React 18 + TS + Leaflet GIS 3D Cockpit (:5174)</a:t>
+            </a:r>
+          </a:p>
+          <a:p>
+            <a:pPr>
+              <a:spcAft>
+                <a:spcPts val="600"/>
+              </a:spcAft>
+              <a:defRPr sz="1000">
+                <a:solidFill>
+                  <a:srgbClr val="64748B"/>
+                </a:solidFill>
+              </a:defRPr>
+            </a:pPr>
+            <a:r>
+              <a:t>• T-72h to Landfall Temporal Playback Scrubber</a:t>
+            </a:r>
+          </a:p>
+          <a:p>
+            <a:pPr>
+              <a:spcAft>
+                <a:spcPts val="600"/>
+              </a:spcAft>
+              <a:defRPr sz="1000">
+                <a:solidFill>
+                  <a:srgbClr val="64748B"/>
+                </a:solidFill>
+              </a:defRPr>
+            </a:pPr>
+            <a:r>
+              <a:t>• Role-Differentiated SOPs &amp; 22 Indic Audio</a:t>
+            </a:r>
+          </a:p>
+        </p:txBody>
+      </p:sp>
+      <p:sp>
+        <p:nvSpPr>
+          <p:cNvPr id="16" name="Rounded Rectangle 15"/>
+          <p:cNvSpPr/>
+          <p:nvPr/>
+        </p:nvSpPr>
+        <p:spPr>
+          <a:xfrm>
+            <a:off x="731520" y="5486400"/>
+            <a:ext cx="10698480" cy="731520"/>
+          </a:xfrm>
+          <a:prstGeom prst="roundRect">
+            <a:avLst/>
+          </a:prstGeom>
+          <a:solidFill>
+            <a:srgbClr val="F1F5F9"/>
+          </a:solidFill>
+          <a:ln>
+            <a:solidFill>
+              <a:srgbClr val="CBD5E1"/>
+            </a:solidFill>
+          </a:ln>
+        </p:spPr>
+        <p:style>
+          <a:lnRef idx="1">
+            <a:schemeClr val="accent1"/>
+          </a:lnRef>
+          <a:fillRef idx="3">
+            <a:schemeClr val="accent1"/>
+          </a:fillRef>
+          <a:effectRef idx="2">
+            <a:schemeClr val="accent1"/>
+          </a:effectRef>
+          <a:fontRef idx="minor">
+            <a:schemeClr val="lt1"/>
+          </a:fontRef>
+        </p:style>
+        <p:txBody>
+          <a:bodyPr rtlCol="0" anchor="ctr"/>
+          <a:lstStyle/>
           <a:p>
             <a:pPr algn="ctr">
-              <a:spcAft>
-                <a:spcPts val="800"/>
-              </a:spcAft>
-              <a:defRPr sz="1300">
-                <a:solidFill>
-                  <a:srgbClr val="94A3B8"/>
-                </a:solidFill>
-              </a:defRPr>
-            </a:pPr>
-            <a:r>
-              <a:t>Ready for immediate deployment across NDMA, OSDMA, and Coastal APAC Disaster Management Authorities.</a:t>
-            </a:r>
-          </a:p>
-          <a:p>
-            <a:pPr algn="ctr">
-              <a:defRPr sz="1100" b="1">
-                <a:solidFill>
-                  <a:srgbClr val="00D1B2"/>
-                </a:solidFill>
-              </a:defRPr>
-            </a:pPr>
-            <a:r>
-              <a:t>⚡ Ingestion Poller (Port 8001)  •  Core Simulation Engine (Port 8010)  •  Vite Command Center (Port 5174)  •  Zero Legacy Disruption</a:t>
+              <a:defRPr sz="1200" b="1">
+                <a:solidFill>
+                  <a:srgbClr val="00836C"/>
+                </a:solidFill>
+              </a:defRPr>
+            </a:pPr>
+            <a:r>
+              <a:t>⚡ Decoupled Pipeline: External Feeds ➔ Ingestion Worker (:8001) ➔ Spatial DB ➔ Core Engine (:8010) ➔ React GIS (:5174)</a:t>
             </a:r>
           </a:p>
         </p:txBody>
@@ -6311,7 +7016,7 @@
               </a:defRPr>
             </a:pPr>
             <a:r>
-              <a:t>✓ Parametric Liquidity Relief Pass</a:t>
+              <a:t>✓ Parametric Relief QR Pass</a:t>
             </a:r>
           </a:p>
           <a:p>

</xml_diff>

<commit_message>
Add user-provided System Architecture Flowchart diagram as Slide 11 in PPTX and PDF
</commit_message>
<xml_diff>
--- a/pitch-deck/PRAHAR-Pitch-Deck.pptx
+++ b/pitch-deck/PRAHAR-Pitch-Deck.pptx
@@ -15,6 +15,7 @@
     <p:sldId id="263" r:id="rId14"/>
     <p:sldId id="264" r:id="rId15"/>
     <p:sldId id="265" r:id="rId16"/>
+    <p:sldId id="266" r:id="rId17"/>
   </p:sldIdLst>
   <p:sldSz cx="12191695" cy="6858000" type="screen4x3"/>
   <p:notesSz cx="6858000" cy="9144000"/>
@@ -3606,7 +3607,7 @@
               </a:defRPr>
             </a:pPr>
             <a:r>
-              <a:t>System Architecture</a:t>
+              <a:t>System Architecture &amp; Decoupled Pipelines</a:t>
             </a:r>
           </a:p>
         </p:txBody>
@@ -4420,6 +4421,188 @@
             </a:pPr>
             <a:r>
               <a:t>⚡ Decoupled Pipeline: External Feeds ➔ Ingestion Worker (:8001) ➔ Spatial DB ➔ Core Engine (:8010) ➔ React GIS (:5174)</a:t>
+            </a:r>
+          </a:p>
+        </p:txBody>
+      </p:sp>
+    </p:spTree>
+  </p:cSld>
+  <p:clrMapOvr>
+    <a:masterClrMapping/>
+  </p:clrMapOvr>
+</p:sld>
+</file>
+
+<file path=ppt/slides/slide11.xml><?xml version="1.0" encoding="utf-8"?>
+<p:sld xmlns:a="http://schemas.openxmlformats.org/drawingml/2006/main" xmlns:p="http://schemas.openxmlformats.org/presentationml/2006/main" xmlns:r="http://schemas.openxmlformats.org/officeDocument/2006/relationships">
+  <p:cSld>
+    <p:bg>
+      <p:bgPr>
+        <a:solidFill>
+          <a:srgbClr val="0D1116"/>
+        </a:solidFill>
+        <a:effectLst/>
+      </p:bgPr>
+    </p:bg>
+    <p:spTree>
+      <p:nvGrpSpPr>
+        <p:cNvPr id="1" name=""/>
+        <p:cNvGrpSpPr/>
+        <p:nvPr/>
+      </p:nvGrpSpPr>
+      <p:grpSpPr/>
+      <p:sp>
+        <p:nvSpPr>
+          <p:cNvPr id="2" name="Rectangle 1"/>
+          <p:cNvSpPr/>
+          <p:nvPr/>
+        </p:nvSpPr>
+        <p:spPr>
+          <a:xfrm>
+            <a:off x="731520" y="457200"/>
+            <a:ext cx="73152" cy="411480"/>
+          </a:xfrm>
+          <a:prstGeom prst="rect">
+            <a:avLst/>
+          </a:prstGeom>
+          <a:solidFill>
+            <a:srgbClr val="00D1B2"/>
+          </a:solidFill>
+          <a:ln>
+            <a:noFill/>
+          </a:ln>
+        </p:spPr>
+        <p:style>
+          <a:lnRef idx="1">
+            <a:schemeClr val="accent1"/>
+          </a:lnRef>
+          <a:fillRef idx="3">
+            <a:schemeClr val="accent1"/>
+          </a:fillRef>
+          <a:effectRef idx="2">
+            <a:schemeClr val="accent1"/>
+          </a:effectRef>
+          <a:fontRef idx="minor">
+            <a:schemeClr val="lt1"/>
+          </a:fontRef>
+        </p:style>
+        <p:txBody>
+          <a:bodyPr rtlCol="0" anchor="ctr"/>
+          <a:lstStyle/>
+          <a:p>
+            <a:pPr algn="ctr"/>
+          </a:p>
+        </p:txBody>
+      </p:sp>
+      <p:sp>
+        <p:nvSpPr>
+          <p:cNvPr id="3" name="TextBox 2"/>
+          <p:cNvSpPr txBox="1"/>
+          <p:nvPr/>
+        </p:nvSpPr>
+        <p:spPr>
+          <a:xfrm>
+            <a:off x="914400" y="411480"/>
+            <a:ext cx="10515600" cy="502920"/>
+          </a:xfrm>
+          <a:prstGeom prst="rect">
+            <a:avLst/>
+          </a:prstGeom>
+          <a:noFill/>
+        </p:spPr>
+        <p:txBody>
+          <a:bodyPr wrap="square" lIns="0" tIns="0" rIns="0" bIns="0">
+            <a:spAutoFit/>
+          </a:bodyPr>
+          <a:lstStyle/>
+          <a:p>
+            <a:pPr>
+              <a:defRPr sz="2400" b="1">
+                <a:solidFill>
+                  <a:srgbClr val="FFFFFF"/>
+                </a:solidFill>
+              </a:defRPr>
+            </a:pPr>
+            <a:r>
+              <a:t>End-to-End System Data Flow Diagram</a:t>
+            </a:r>
+          </a:p>
+        </p:txBody>
+      </p:sp>
+      <p:pic>
+        <p:nvPicPr>
+          <p:cNvPr id="4" name="Picture 3" descr="system_architecture_diagram.png"/>
+          <p:cNvPicPr>
+            <a:picLocks noChangeAspect="1"/>
+          </p:cNvPicPr>
+          <p:nvPr/>
+        </p:nvPicPr>
+        <p:blipFill>
+          <a:blip r:embed="rId2"/>
+          <a:stretch>
+            <a:fillRect/>
+          </a:stretch>
+        </p:blipFill>
+        <p:spPr>
+          <a:xfrm>
+            <a:off x="731520" y="1188720"/>
+            <a:ext cx="10698480" cy="4114800"/>
+          </a:xfrm>
+          <a:prstGeom prst="rect">
+            <a:avLst/>
+          </a:prstGeom>
+        </p:spPr>
+      </p:pic>
+      <p:sp>
+        <p:nvSpPr>
+          <p:cNvPr id="5" name="Rounded Rectangle 4"/>
+          <p:cNvSpPr/>
+          <p:nvPr/>
+        </p:nvSpPr>
+        <p:spPr>
+          <a:xfrm>
+            <a:off x="731520" y="5486400"/>
+            <a:ext cx="10698480" cy="822960"/>
+          </a:xfrm>
+          <a:prstGeom prst="roundRect">
+            <a:avLst/>
+          </a:prstGeom>
+          <a:solidFill>
+            <a:srgbClr val="161B22"/>
+          </a:solidFill>
+          <a:ln>
+            <a:solidFill>
+              <a:srgbClr val="30363D"/>
+            </a:solidFill>
+          </a:ln>
+        </p:spPr>
+        <p:style>
+          <a:lnRef idx="1">
+            <a:schemeClr val="accent1"/>
+          </a:lnRef>
+          <a:fillRef idx="3">
+            <a:schemeClr val="accent1"/>
+          </a:fillRef>
+          <a:effectRef idx="2">
+            <a:schemeClr val="accent1"/>
+          </a:effectRef>
+          <a:fontRef idx="minor">
+            <a:schemeClr val="lt1"/>
+          </a:fontRef>
+        </p:style>
+        <p:txBody>
+          <a:bodyPr rtlCol="0" anchor="ctr" wrap="square"/>
+          <a:lstStyle/>
+          <a:p>
+            <a:pPr algn="ctr">
+              <a:defRPr sz="1150" b="1">
+                <a:solidFill>
+                  <a:srgbClr val="00D1B2"/>
+                </a:solidFill>
+              </a:defRPr>
+            </a:pPr>
+            <a:r>
+              <a:t>⚡ Architectural Flow: External Feeds &amp; GEE ➔ Async Ingestion Engine (:8001) ➔ PostGIS / Redis ➔ FastAPI Engine (:8010) ➔ SLOSH / NetworkX / Gemini Flash ➔ War Room &amp; 22 Indic Audio (:5174)</a:t>
             </a:r>
           </a:p>
         </p:txBody>

</xml_diff>

<commit_message>
Update pitch deck Slide 11 with native vector system architecture diagram
</commit_message>
<xml_diff>
--- a/pitch-deck/PRAHAR-Pitch-Deck.pptx
+++ b/pitch-deck/PRAHAR-Pitch-Deck.pptx
@@ -3542,7 +3542,7 @@
         </p:nvSpPr>
         <p:spPr>
           <a:xfrm>
-            <a:off x="731520" y="457200"/>
+            <a:off x="731520" y="365760"/>
             <a:ext cx="73152" cy="411480"/>
           </a:xfrm>
           <a:prstGeom prst="rect">
@@ -3585,7 +3585,7 @@
         </p:nvSpPr>
         <p:spPr>
           <a:xfrm>
-            <a:off x="914400" y="411480"/>
+            <a:off x="914400" y="320040"/>
             <a:ext cx="10515600" cy="502920"/>
           </a:xfrm>
           <a:prstGeom prst="rect">
@@ -3600,7 +3600,7 @@
           <a:lstStyle/>
           <a:p>
             <a:pPr>
-              <a:defRPr sz="2400" b="1">
+              <a:defRPr sz="2200" b="1">
                 <a:solidFill>
                   <a:srgbClr val="0F172A"/>
                 </a:solidFill>
@@ -4439,7 +4439,7 @@
     <p:bg>
       <p:bgPr>
         <a:solidFill>
-          <a:srgbClr val="0D1116"/>
+          <a:srgbClr val="071523"/>
         </a:solidFill>
         <a:effectLst/>
       </p:bgPr>
@@ -4459,7 +4459,7 @@
         </p:nvSpPr>
         <p:spPr>
           <a:xfrm>
-            <a:off x="731520" y="457200"/>
+            <a:off x="731520" y="365760"/>
             <a:ext cx="73152" cy="411480"/>
           </a:xfrm>
           <a:prstGeom prst="rect">
@@ -4502,7 +4502,7 @@
         </p:nvSpPr>
         <p:spPr>
           <a:xfrm>
-            <a:off x="914400" y="411480"/>
+            <a:off x="914400" y="320040"/>
             <a:ext cx="10515600" cy="502920"/>
           </a:xfrm>
           <a:prstGeom prst="rect">
@@ -4517,52 +4517,1730 @@
           <a:lstStyle/>
           <a:p>
             <a:pPr>
-              <a:defRPr sz="2400" b="1">
+              <a:defRPr sz="2200" b="1">
                 <a:solidFill>
                   <a:srgbClr val="FFFFFF"/>
                 </a:solidFill>
               </a:defRPr>
             </a:pPr>
             <a:r>
-              <a:t>End-to-End System Data Flow Diagram</a:t>
-            </a:r>
-          </a:p>
-        </p:txBody>
-      </p:sp>
-      <p:pic>
-        <p:nvPicPr>
-          <p:cNvPr id="4" name="Picture 3" descr="system_architecture_diagram.png"/>
-          <p:cNvPicPr>
-            <a:picLocks noChangeAspect="1"/>
-          </p:cNvPicPr>
-          <p:nvPr/>
-        </p:nvPicPr>
-        <p:blipFill>
-          <a:blip r:embed="rId2"/>
-          <a:stretch>
-            <a:fillRect/>
-          </a:stretch>
-        </p:blipFill>
-        <p:spPr>
-          <a:xfrm>
-            <a:off x="731520" y="1188720"/>
-            <a:ext cx="10698480" cy="4114800"/>
+              <a:t>End-to-End System Block Diagram</a:t>
+            </a:r>
+          </a:p>
+        </p:txBody>
+      </p:sp>
+      <p:sp>
+        <p:nvSpPr>
+          <p:cNvPr id="4" name="Rounded Rectangle 3"/>
+          <p:cNvSpPr/>
+          <p:nvPr/>
+        </p:nvSpPr>
+        <p:spPr>
+          <a:xfrm>
+            <a:off x="731520" y="960120"/>
+            <a:ext cx="10698480" cy="1051560"/>
+          </a:xfrm>
+          <a:prstGeom prst="roundRect">
+            <a:avLst/>
+          </a:prstGeom>
+          <a:solidFill>
+            <a:srgbClr val="0F213C"/>
+          </a:solidFill>
+          <a:ln>
+            <a:solidFill>
+              <a:srgbClr val="38BDF8"/>
+            </a:solidFill>
+          </a:ln>
+        </p:spPr>
+        <p:style>
+          <a:lnRef idx="1">
+            <a:schemeClr val="accent1"/>
+          </a:lnRef>
+          <a:fillRef idx="3">
+            <a:schemeClr val="accent1"/>
+          </a:fillRef>
+          <a:effectRef idx="2">
+            <a:schemeClr val="accent1"/>
+          </a:effectRef>
+          <a:fontRef idx="minor">
+            <a:schemeClr val="lt1"/>
+          </a:fontRef>
+        </p:style>
+        <p:txBody>
+          <a:bodyPr rtlCol="0" anchor="ctr"/>
+          <a:lstStyle/>
+          <a:p>
+            <a:pPr algn="ctr"/>
+          </a:p>
+        </p:txBody>
+      </p:sp>
+      <p:sp>
+        <p:nvSpPr>
+          <p:cNvPr id="5" name="TextBox 4"/>
+          <p:cNvSpPr txBox="1"/>
+          <p:nvPr/>
+        </p:nvSpPr>
+        <p:spPr>
+          <a:xfrm>
+            <a:off x="868680" y="987552"/>
+            <a:ext cx="10424160" cy="228600"/>
           </a:xfrm>
           <a:prstGeom prst="rect">
             <a:avLst/>
           </a:prstGeom>
-        </p:spPr>
-      </p:pic>
-      <p:sp>
-        <p:nvSpPr>
-          <p:cNvPr id="5" name="Rounded Rectangle 4"/>
+          <a:noFill/>
+        </p:spPr>
+        <p:txBody>
+          <a:bodyPr wrap="none">
+            <a:spAutoFit/>
+          </a:bodyPr>
+          <a:lstStyle/>
+          <a:p>
+            <a:pPr>
+              <a:defRPr sz="950" b="1">
+                <a:solidFill>
+                  <a:srgbClr val="38BDF8"/>
+                </a:solidFill>
+              </a:defRPr>
+            </a:pPr>
+            <a:r>
+              <a:t>1. EXTERNAL FEEDS &amp; SATELLITE TELEMETRY</a:t>
+            </a:r>
+          </a:p>
+        </p:txBody>
+      </p:sp>
+      <p:sp>
+        <p:nvSpPr>
+          <p:cNvPr id="6" name="Rounded Rectangle 5"/>
           <p:cNvSpPr/>
           <p:nvPr/>
         </p:nvSpPr>
         <p:spPr>
           <a:xfrm>
-            <a:off x="731520" y="5486400"/>
-            <a:ext cx="10698480" cy="822960"/>
+            <a:off x="914400" y="1234440"/>
+            <a:ext cx="2468880" cy="658368"/>
+          </a:xfrm>
+          <a:prstGeom prst="roundRect">
+            <a:avLst/>
+          </a:prstGeom>
+          <a:solidFill>
+            <a:srgbClr val="0B1C30"/>
+          </a:solidFill>
+          <a:ln>
+            <a:solidFill>
+              <a:srgbClr val="1E3A5F"/>
+            </a:solidFill>
+          </a:ln>
+        </p:spPr>
+        <p:style>
+          <a:lnRef idx="1">
+            <a:schemeClr val="accent1"/>
+          </a:lnRef>
+          <a:fillRef idx="3">
+            <a:schemeClr val="accent1"/>
+          </a:fillRef>
+          <a:effectRef idx="2">
+            <a:schemeClr val="accent1"/>
+          </a:effectRef>
+          <a:fontRef idx="minor">
+            <a:schemeClr val="lt1"/>
+          </a:fontRef>
+        </p:style>
+        <p:txBody>
+          <a:bodyPr rtlCol="0" anchor="ctr" wrap="square" tIns="73152"/>
+          <a:lstStyle/>
+          <a:p>
+            <a:pPr algn="ctr">
+              <a:defRPr sz="1100" b="1">
+                <a:solidFill>
+                  <a:srgbClr val="FFFFFF"/>
+                </a:solidFill>
+              </a:defRPr>
+            </a:pPr>
+            <a:r>
+              <a:t>🛰️ IMD / JTWC</a:t>
+            </a:r>
+          </a:p>
+          <a:p>
+            <a:pPr>
+              <a:defRPr sz="850">
+                <a:solidFill>
+                  <a:srgbClr val="94A3B8"/>
+                </a:solidFill>
+              </a:defRPr>
+            </a:pPr>
+            <a:r>
+              <a:t>Cyclone track coordinates, wind &amp; pressure</a:t>
+            </a:r>
+          </a:p>
+        </p:txBody>
+      </p:sp>
+      <p:sp>
+        <p:nvSpPr>
+          <p:cNvPr id="7" name="Rounded Rectangle 6"/>
+          <p:cNvSpPr/>
+          <p:nvPr/>
+        </p:nvSpPr>
+        <p:spPr>
+          <a:xfrm>
+            <a:off x="3547872" y="1234440"/>
+            <a:ext cx="2468880" cy="658368"/>
+          </a:xfrm>
+          <a:prstGeom prst="roundRect">
+            <a:avLst/>
+          </a:prstGeom>
+          <a:solidFill>
+            <a:srgbClr val="0B1C30"/>
+          </a:solidFill>
+          <a:ln>
+            <a:solidFill>
+              <a:srgbClr val="1E3A5F"/>
+            </a:solidFill>
+          </a:ln>
+        </p:spPr>
+        <p:style>
+          <a:lnRef idx="1">
+            <a:schemeClr val="accent1"/>
+          </a:lnRef>
+          <a:fillRef idx="3">
+            <a:schemeClr val="accent1"/>
+          </a:fillRef>
+          <a:effectRef idx="2">
+            <a:schemeClr val="accent1"/>
+          </a:effectRef>
+          <a:fontRef idx="minor">
+            <a:schemeClr val="lt1"/>
+          </a:fontRef>
+        </p:style>
+        <p:txBody>
+          <a:bodyPr rtlCol="0" anchor="ctr" wrap="square" tIns="73152"/>
+          <a:lstStyle/>
+          <a:p>
+            <a:pPr algn="ctr">
+              <a:defRPr sz="1100" b="1">
+                <a:solidFill>
+                  <a:srgbClr val="FFFFFF"/>
+                </a:solidFill>
+              </a:defRPr>
+            </a:pPr>
+            <a:r>
+              <a:t>🌐 Google Earth Engine</a:t>
+            </a:r>
+          </a:p>
+          <a:p>
+            <a:pPr>
+              <a:defRPr sz="850">
+                <a:solidFill>
+                  <a:srgbClr val="94A3B8"/>
+                </a:solidFill>
+              </a:defRPr>
+            </a:pPr>
+            <a:r>
+              <a:t>Copernicus 30m DEM, Sentinel-1 &amp; GPM</a:t>
+            </a:r>
+          </a:p>
+        </p:txBody>
+      </p:sp>
+      <p:sp>
+        <p:nvSpPr>
+          <p:cNvPr id="8" name="Rounded Rectangle 7"/>
+          <p:cNvSpPr/>
+          <p:nvPr/>
+        </p:nvSpPr>
+        <p:spPr>
+          <a:xfrm>
+            <a:off x="6181344" y="1234440"/>
+            <a:ext cx="2468880" cy="658368"/>
+          </a:xfrm>
+          <a:prstGeom prst="roundRect">
+            <a:avLst/>
+          </a:prstGeom>
+          <a:solidFill>
+            <a:srgbClr val="0B1C30"/>
+          </a:solidFill>
+          <a:ln>
+            <a:solidFill>
+              <a:srgbClr val="1E3A5F"/>
+            </a:solidFill>
+          </a:ln>
+        </p:spPr>
+        <p:style>
+          <a:lnRef idx="1">
+            <a:schemeClr val="accent1"/>
+          </a:lnRef>
+          <a:fillRef idx="3">
+            <a:schemeClr val="accent1"/>
+          </a:fillRef>
+          <a:effectRef idx="2">
+            <a:schemeClr val="accent1"/>
+          </a:effectRef>
+          <a:fontRef idx="minor">
+            <a:schemeClr val="lt1"/>
+          </a:fontRef>
+        </p:style>
+        <p:txBody>
+          <a:bodyPr rtlCol="0" anchor="ctr" wrap="square" tIns="73152"/>
+          <a:lstStyle/>
+          <a:p>
+            <a:pPr algn="ctr">
+              <a:defRPr sz="1100" b="1">
+                <a:solidFill>
+                  <a:srgbClr val="FFFFFF"/>
+                </a:solidFill>
+              </a:defRPr>
+            </a:pPr>
+            <a:r>
+              <a:t>🗺️ OSM Overpass</a:t>
+            </a:r>
+          </a:p>
+          <a:p>
+            <a:pPr>
+              <a:defRPr sz="850">
+                <a:solidFill>
+                  <a:srgbClr val="94A3B8"/>
+                </a:solidFill>
+              </a:defRPr>
+            </a:pPr>
+            <a:r>
+              <a:t>Hospitals, Sub-stations, Bridges &amp; Shelters</a:t>
+            </a:r>
+          </a:p>
+        </p:txBody>
+      </p:sp>
+      <p:sp>
+        <p:nvSpPr>
+          <p:cNvPr id="9" name="Rounded Rectangle 8"/>
+          <p:cNvSpPr/>
+          <p:nvPr/>
+        </p:nvSpPr>
+        <p:spPr>
+          <a:xfrm>
+            <a:off x="8814816" y="1234440"/>
+            <a:ext cx="2468880" cy="658368"/>
+          </a:xfrm>
+          <a:prstGeom prst="roundRect">
+            <a:avLst/>
+          </a:prstGeom>
+          <a:solidFill>
+            <a:srgbClr val="0B1C30"/>
+          </a:solidFill>
+          <a:ln>
+            <a:solidFill>
+              <a:srgbClr val="1E3A5F"/>
+            </a:solidFill>
+          </a:ln>
+        </p:spPr>
+        <p:style>
+          <a:lnRef idx="1">
+            <a:schemeClr val="accent1"/>
+          </a:lnRef>
+          <a:fillRef idx="3">
+            <a:schemeClr val="accent1"/>
+          </a:fillRef>
+          <a:effectRef idx="2">
+            <a:schemeClr val="accent1"/>
+          </a:effectRef>
+          <a:fontRef idx="minor">
+            <a:schemeClr val="lt1"/>
+          </a:fontRef>
+        </p:style>
+        <p:txBody>
+          <a:bodyPr rtlCol="0" anchor="ctr" wrap="square" tIns="73152"/>
+          <a:lstStyle/>
+          <a:p>
+            <a:pPr algn="ctr">
+              <a:defRPr sz="1100" b="1">
+                <a:solidFill>
+                  <a:srgbClr val="FFFFFF"/>
+                </a:solidFill>
+              </a:defRPr>
+            </a:pPr>
+            <a:r>
+              <a:t>🌊 INCOIS / NOAA</a:t>
+            </a:r>
+          </a:p>
+          <a:p>
+            <a:pPr>
+              <a:defRPr sz="850">
+                <a:solidFill>
+                  <a:srgbClr val="94A3B8"/>
+                </a:solidFill>
+              </a:defRPr>
+            </a:pPr>
+            <a:r>
+              <a:t>Coastal tide gauges, SST &amp; bathymetry</a:t>
+            </a:r>
+          </a:p>
+        </p:txBody>
+      </p:sp>
+      <p:sp>
+        <p:nvSpPr>
+          <p:cNvPr id="10" name="Rounded Rectangle 9"/>
+          <p:cNvSpPr/>
+          <p:nvPr/>
+        </p:nvSpPr>
+        <p:spPr>
+          <a:xfrm>
+            <a:off x="731520" y="2148840"/>
+            <a:ext cx="6217920" cy="1280160"/>
+          </a:xfrm>
+          <a:prstGeom prst="roundRect">
+            <a:avLst/>
+          </a:prstGeom>
+          <a:solidFill>
+            <a:srgbClr val="0F213C"/>
+          </a:solidFill>
+          <a:ln>
+            <a:solidFill>
+              <a:srgbClr val="00D1B2"/>
+            </a:solidFill>
+          </a:ln>
+        </p:spPr>
+        <p:style>
+          <a:lnRef idx="1">
+            <a:schemeClr val="accent1"/>
+          </a:lnRef>
+          <a:fillRef idx="3">
+            <a:schemeClr val="accent1"/>
+          </a:fillRef>
+          <a:effectRef idx="2">
+            <a:schemeClr val="accent1"/>
+          </a:effectRef>
+          <a:fontRef idx="minor">
+            <a:schemeClr val="lt1"/>
+          </a:fontRef>
+        </p:style>
+        <p:txBody>
+          <a:bodyPr rtlCol="0" anchor="ctr"/>
+          <a:lstStyle/>
+          <a:p>
+            <a:pPr algn="ctr"/>
+          </a:p>
+        </p:txBody>
+      </p:sp>
+      <p:sp>
+        <p:nvSpPr>
+          <p:cNvPr id="11" name="TextBox 10"/>
+          <p:cNvSpPr txBox="1"/>
+          <p:nvPr/>
+        </p:nvSpPr>
+        <p:spPr>
+          <a:xfrm>
+            <a:off x="868680" y="2176272"/>
+            <a:ext cx="5943600" cy="228600"/>
+          </a:xfrm>
+          <a:prstGeom prst="rect">
+            <a:avLst/>
+          </a:prstGeom>
+          <a:noFill/>
+        </p:spPr>
+        <p:txBody>
+          <a:bodyPr wrap="none">
+            <a:spAutoFit/>
+          </a:bodyPr>
+          <a:lstStyle/>
+          <a:p>
+            <a:pPr>
+              <a:defRPr sz="950" b="1">
+                <a:solidFill>
+                  <a:srgbClr val="00D1B2"/>
+                </a:solidFill>
+              </a:defRPr>
+            </a:pPr>
+            <a:r>
+              <a:t>2. DATA INGESTION MICROSERVICE (services/ingestion :8001)</a:t>
+            </a:r>
+          </a:p>
+        </p:txBody>
+      </p:sp>
+      <p:sp>
+        <p:nvSpPr>
+          <p:cNvPr id="12" name="Rounded Rectangle 11"/>
+          <p:cNvSpPr/>
+          <p:nvPr/>
+        </p:nvSpPr>
+        <p:spPr>
+          <a:xfrm>
+            <a:off x="914400" y="2423160"/>
+            <a:ext cx="2880360" cy="384048"/>
+          </a:xfrm>
+          <a:prstGeom prst="roundRect">
+            <a:avLst/>
+          </a:prstGeom>
+          <a:solidFill>
+            <a:srgbClr val="092026"/>
+          </a:solidFill>
+          <a:ln>
+            <a:solidFill>
+              <a:srgbClr val="005A4A"/>
+            </a:solidFill>
+          </a:ln>
+        </p:spPr>
+        <p:style>
+          <a:lnRef idx="1">
+            <a:schemeClr val="accent1"/>
+          </a:lnRef>
+          <a:fillRef idx="3">
+            <a:schemeClr val="accent1"/>
+          </a:fillRef>
+          <a:effectRef idx="2">
+            <a:schemeClr val="accent1"/>
+          </a:effectRef>
+          <a:fontRef idx="minor">
+            <a:schemeClr val="lt1"/>
+          </a:fontRef>
+        </p:style>
+        <p:txBody>
+          <a:bodyPr rtlCol="0" anchor="ctr" wrap="square" tIns="36576"/>
+          <a:lstStyle/>
+          <a:p>
+            <a:pPr algn="ctr">
+              <a:defRPr sz="900" b="1">
+                <a:solidFill>
+                  <a:srgbClr val="A7F3D0"/>
+                </a:solidFill>
+              </a:defRPr>
+            </a:pPr>
+            <a:r>
+              <a:t>⚡ Async Worker : Non-blocking poller daemon</a:t>
+            </a:r>
+          </a:p>
+        </p:txBody>
+      </p:sp>
+      <p:sp>
+        <p:nvSpPr>
+          <p:cNvPr id="13" name="Rounded Rectangle 12"/>
+          <p:cNvSpPr/>
+          <p:nvPr/>
+        </p:nvSpPr>
+        <p:spPr>
+          <a:xfrm>
+            <a:off x="3886200" y="2423160"/>
+            <a:ext cx="2880360" cy="384048"/>
+          </a:xfrm>
+          <a:prstGeom prst="roundRect">
+            <a:avLst/>
+          </a:prstGeom>
+          <a:solidFill>
+            <a:srgbClr val="092026"/>
+          </a:solidFill>
+          <a:ln>
+            <a:solidFill>
+              <a:srgbClr val="005A4A"/>
+            </a:solidFill>
+          </a:ln>
+        </p:spPr>
+        <p:style>
+          <a:lnRef idx="1">
+            <a:schemeClr val="accent1"/>
+          </a:lnRef>
+          <a:fillRef idx="3">
+            <a:schemeClr val="accent1"/>
+          </a:fillRef>
+          <a:effectRef idx="2">
+            <a:schemeClr val="accent1"/>
+          </a:effectRef>
+          <a:fontRef idx="minor">
+            <a:schemeClr val="lt1"/>
+          </a:fontRef>
+        </p:style>
+        <p:txBody>
+          <a:bodyPr rtlCol="0" anchor="ctr" wrap="square" tIns="36576"/>
+          <a:lstStyle/>
+          <a:p>
+            <a:pPr algn="ctr">
+              <a:defRPr sz="900" b="1">
+                <a:solidFill>
+                  <a:srgbClr val="A7F3D0"/>
+                </a:solidFill>
+              </a:defRPr>
+            </a:pPr>
+            <a:r>
+              <a:t>🌀 Track Normalizer : Cone generator</a:t>
+            </a:r>
+          </a:p>
+        </p:txBody>
+      </p:sp>
+      <p:sp>
+        <p:nvSpPr>
+          <p:cNvPr id="14" name="Rounded Rectangle 13"/>
+          <p:cNvSpPr/>
+          <p:nvPr/>
+        </p:nvSpPr>
+        <p:spPr>
+          <a:xfrm>
+            <a:off x="914400" y="2862072"/>
+            <a:ext cx="2880360" cy="384048"/>
+          </a:xfrm>
+          <a:prstGeom prst="roundRect">
+            <a:avLst/>
+          </a:prstGeom>
+          <a:solidFill>
+            <a:srgbClr val="092026"/>
+          </a:solidFill>
+          <a:ln>
+            <a:solidFill>
+              <a:srgbClr val="005A4A"/>
+            </a:solidFill>
+          </a:ln>
+        </p:spPr>
+        <p:style>
+          <a:lnRef idx="1">
+            <a:schemeClr val="accent1"/>
+          </a:lnRef>
+          <a:fillRef idx="3">
+            <a:schemeClr val="accent1"/>
+          </a:fillRef>
+          <a:effectRef idx="2">
+            <a:schemeClr val="accent1"/>
+          </a:effectRef>
+          <a:fontRef idx="minor">
+            <a:schemeClr val="lt1"/>
+          </a:fontRef>
+        </p:style>
+        <p:txBody>
+          <a:bodyPr rtlCol="0" anchor="ctr" wrap="square" tIns="36576"/>
+          <a:lstStyle/>
+          <a:p>
+            <a:pPr algn="ctr">
+              <a:defRPr sz="900" b="1">
+                <a:solidFill>
+                  <a:srgbClr val="A7F3D0"/>
+                </a:solidFill>
+              </a:defRPr>
+            </a:pPr>
+            <a:r>
+              <a:t>🏔️ Raster Pipeline : GEE DEM sampler</a:t>
+            </a:r>
+          </a:p>
+        </p:txBody>
+      </p:sp>
+      <p:sp>
+        <p:nvSpPr>
+          <p:cNvPr id="15" name="Rounded Rectangle 14"/>
+          <p:cNvSpPr/>
+          <p:nvPr/>
+        </p:nvSpPr>
+        <p:spPr>
+          <a:xfrm>
+            <a:off x="3886200" y="2862072"/>
+            <a:ext cx="2880360" cy="384048"/>
+          </a:xfrm>
+          <a:prstGeom prst="roundRect">
+            <a:avLst/>
+          </a:prstGeom>
+          <a:solidFill>
+            <a:srgbClr val="092026"/>
+          </a:solidFill>
+          <a:ln>
+            <a:solidFill>
+              <a:srgbClr val="005A4A"/>
+            </a:solidFill>
+          </a:ln>
+        </p:spPr>
+        <p:style>
+          <a:lnRef idx="1">
+            <a:schemeClr val="accent1"/>
+          </a:lnRef>
+          <a:fillRef idx="3">
+            <a:schemeClr val="accent1"/>
+          </a:fillRef>
+          <a:effectRef idx="2">
+            <a:schemeClr val="accent1"/>
+          </a:effectRef>
+          <a:fontRef idx="minor">
+            <a:schemeClr val="lt1"/>
+          </a:fontRef>
+        </p:style>
+        <p:txBody>
+          <a:bodyPr rtlCol="0" anchor="ctr" wrap="square" tIns="36576"/>
+          <a:lstStyle/>
+          <a:p>
+            <a:pPr algn="ctr">
+              <a:defRPr sz="900" b="1">
+                <a:solidFill>
+                  <a:srgbClr val="A7F3D0"/>
+                </a:solidFill>
+              </a:defRPr>
+            </a:pPr>
+            <a:r>
+              <a:t>🏗️ OSM Extractor : Spatial lifelines parser</a:t>
+            </a:r>
+          </a:p>
+        </p:txBody>
+      </p:sp>
+      <p:sp>
+        <p:nvSpPr>
+          <p:cNvPr id="16" name="Rounded Rectangle 15"/>
+          <p:cNvSpPr/>
+          <p:nvPr/>
+        </p:nvSpPr>
+        <p:spPr>
+          <a:xfrm>
+            <a:off x="7132320" y="2148840"/>
+            <a:ext cx="4297680" cy="1280160"/>
+          </a:xfrm>
+          <a:prstGeom prst="roundRect">
+            <a:avLst/>
+          </a:prstGeom>
+          <a:solidFill>
+            <a:srgbClr val="0F213C"/>
+          </a:solidFill>
+          <a:ln>
+            <a:solidFill>
+              <a:srgbClr val="7C3AED"/>
+            </a:solidFill>
+          </a:ln>
+        </p:spPr>
+        <p:style>
+          <a:lnRef idx="1">
+            <a:schemeClr val="accent1"/>
+          </a:lnRef>
+          <a:fillRef idx="3">
+            <a:schemeClr val="accent1"/>
+          </a:fillRef>
+          <a:effectRef idx="2">
+            <a:schemeClr val="accent1"/>
+          </a:effectRef>
+          <a:fontRef idx="minor">
+            <a:schemeClr val="lt1"/>
+          </a:fontRef>
+        </p:style>
+        <p:txBody>
+          <a:bodyPr rtlCol="0" anchor="ctr"/>
+          <a:lstStyle/>
+          <a:p>
+            <a:pPr algn="ctr"/>
+          </a:p>
+        </p:txBody>
+      </p:sp>
+      <p:sp>
+        <p:nvSpPr>
+          <p:cNvPr id="17" name="TextBox 16"/>
+          <p:cNvSpPr txBox="1"/>
+          <p:nvPr/>
+        </p:nvSpPr>
+        <p:spPr>
+          <a:xfrm>
+            <a:off x="7269480" y="2176272"/>
+            <a:ext cx="4023360" cy="228600"/>
+          </a:xfrm>
+          <a:prstGeom prst="rect">
+            <a:avLst/>
+          </a:prstGeom>
+          <a:noFill/>
+        </p:spPr>
+        <p:txBody>
+          <a:bodyPr wrap="none">
+            <a:spAutoFit/>
+          </a:bodyPr>
+          <a:lstStyle/>
+          <a:p>
+            <a:pPr>
+              <a:defRPr sz="950" b="1">
+                <a:solidFill>
+                  <a:srgbClr val="C4B5FD"/>
+                </a:solidFill>
+              </a:defRPr>
+            </a:pPr>
+            <a:r>
+              <a:t>3. STORAGE &amp; GEO-CACHING TIER</a:t>
+            </a:r>
+          </a:p>
+        </p:txBody>
+      </p:sp>
+      <p:sp>
+        <p:nvSpPr>
+          <p:cNvPr id="18" name="Rounded Rectangle 17"/>
+          <p:cNvSpPr/>
+          <p:nvPr/>
+        </p:nvSpPr>
+        <p:spPr>
+          <a:xfrm>
+            <a:off x="7269480" y="2423160"/>
+            <a:ext cx="4023360" cy="256032"/>
+          </a:xfrm>
+          <a:prstGeom prst="roundRect">
+            <a:avLst/>
+          </a:prstGeom>
+          <a:solidFill>
+            <a:srgbClr val="1E1B4B"/>
+          </a:solidFill>
+          <a:ln>
+            <a:solidFill>
+              <a:srgbClr val="4338CA"/>
+            </a:solidFill>
+          </a:ln>
+        </p:spPr>
+        <p:style>
+          <a:lnRef idx="1">
+            <a:schemeClr val="accent1"/>
+          </a:lnRef>
+          <a:fillRef idx="3">
+            <a:schemeClr val="accent1"/>
+          </a:fillRef>
+          <a:effectRef idx="2">
+            <a:schemeClr val="accent1"/>
+          </a:effectRef>
+          <a:fontRef idx="minor">
+            <a:schemeClr val="lt1"/>
+          </a:fontRef>
+        </p:style>
+        <p:txBody>
+          <a:bodyPr rtlCol="0" anchor="ctr" tIns="18288"/>
+          <a:lstStyle/>
+          <a:p>
+            <a:pPr algn="ctr">
+              <a:defRPr sz="850" b="1">
+                <a:solidFill>
+                  <a:srgbClr val="E0E7FF"/>
+                </a:solidFill>
+              </a:defRPr>
+            </a:pPr>
+            <a:r>
+              <a:t>🐘 PostgreSQL / PostGIS — Spatial DB &amp; Vector Geometries</a:t>
+            </a:r>
+          </a:p>
+        </p:txBody>
+      </p:sp>
+      <p:sp>
+        <p:nvSpPr>
+          <p:cNvPr id="19" name="Rounded Rectangle 18"/>
+          <p:cNvSpPr/>
+          <p:nvPr/>
+        </p:nvSpPr>
+        <p:spPr>
+          <a:xfrm>
+            <a:off x="7269480" y="2724912"/>
+            <a:ext cx="4023360" cy="256032"/>
+          </a:xfrm>
+          <a:prstGeom prst="roundRect">
+            <a:avLst/>
+          </a:prstGeom>
+          <a:solidFill>
+            <a:srgbClr val="1E1B4B"/>
+          </a:solidFill>
+          <a:ln>
+            <a:solidFill>
+              <a:srgbClr val="4338CA"/>
+            </a:solidFill>
+          </a:ln>
+        </p:spPr>
+        <p:style>
+          <a:lnRef idx="1">
+            <a:schemeClr val="accent1"/>
+          </a:lnRef>
+          <a:fillRef idx="3">
+            <a:schemeClr val="accent1"/>
+          </a:fillRef>
+          <a:effectRef idx="2">
+            <a:schemeClr val="accent1"/>
+          </a:effectRef>
+          <a:fontRef idx="minor">
+            <a:schemeClr val="lt1"/>
+          </a:fontRef>
+        </p:style>
+        <p:txBody>
+          <a:bodyPr rtlCol="0" anchor="ctr" tIns="18288"/>
+          <a:lstStyle/>
+          <a:p>
+            <a:pPr algn="ctr">
+              <a:defRPr sz="850" b="1">
+                <a:solidFill>
+                  <a:srgbClr val="E0E7FF"/>
+                </a:solidFill>
+              </a:defRPr>
+            </a:pPr>
+            <a:r>
+              <a:t>⚡ Redis Geo-Cache &amp; Pub/Sub — Real-time Telemetry Stream Cache</a:t>
+            </a:r>
+          </a:p>
+        </p:txBody>
+      </p:sp>
+      <p:sp>
+        <p:nvSpPr>
+          <p:cNvPr id="20" name="Rounded Rectangle 19"/>
+          <p:cNvSpPr/>
+          <p:nvPr/>
+        </p:nvSpPr>
+        <p:spPr>
+          <a:xfrm>
+            <a:off x="7269480" y="3026664"/>
+            <a:ext cx="4023360" cy="256032"/>
+          </a:xfrm>
+          <a:prstGeom prst="roundRect">
+            <a:avLst/>
+          </a:prstGeom>
+          <a:solidFill>
+            <a:srgbClr val="1E1B4B"/>
+          </a:solidFill>
+          <a:ln>
+            <a:solidFill>
+              <a:srgbClr val="4338CA"/>
+            </a:solidFill>
+          </a:ln>
+        </p:spPr>
+        <p:style>
+          <a:lnRef idx="1">
+            <a:schemeClr val="accent1"/>
+          </a:lnRef>
+          <a:fillRef idx="3">
+            <a:schemeClr val="accent1"/>
+          </a:fillRef>
+          <a:effectRef idx="2">
+            <a:schemeClr val="accent1"/>
+          </a:effectRef>
+          <a:fontRef idx="minor">
+            <a:schemeClr val="lt1"/>
+          </a:fontRef>
+        </p:style>
+        <p:txBody>
+          <a:bodyPr rtlCol="0" anchor="ctr" tIns="18288"/>
+          <a:lstStyle/>
+          <a:p>
+            <a:pPr algn="ctr">
+              <a:defRPr sz="850" b="1">
+                <a:solidFill>
+                  <a:srgbClr val="E0E7FF"/>
+                </a:solidFill>
+              </a:defRPr>
+            </a:pPr>
+            <a:r>
+              <a:t>🗺️ GeoTIFF &amp; GeoJSON Store — Inundation Polygons &amp; Elevation Grids</a:t>
+            </a:r>
+          </a:p>
+        </p:txBody>
+      </p:sp>
+      <p:sp>
+        <p:nvSpPr>
+          <p:cNvPr id="21" name="Rounded Rectangle 20"/>
+          <p:cNvSpPr/>
+          <p:nvPr/>
+        </p:nvSpPr>
+        <p:spPr>
+          <a:xfrm>
+            <a:off x="731520" y="3566160"/>
+            <a:ext cx="10698480" cy="1188720"/>
+          </a:xfrm>
+          <a:prstGeom prst="roundRect">
+            <a:avLst/>
+          </a:prstGeom>
+          <a:solidFill>
+            <a:srgbClr val="0F213C"/>
+          </a:solidFill>
+          <a:ln>
+            <a:solidFill>
+              <a:srgbClr val="F58220"/>
+            </a:solidFill>
+          </a:ln>
+        </p:spPr>
+        <p:style>
+          <a:lnRef idx="1">
+            <a:schemeClr val="accent1"/>
+          </a:lnRef>
+          <a:fillRef idx="3">
+            <a:schemeClr val="accent1"/>
+          </a:fillRef>
+          <a:effectRef idx="2">
+            <a:schemeClr val="accent1"/>
+          </a:effectRef>
+          <a:fontRef idx="minor">
+            <a:schemeClr val="lt1"/>
+          </a:fontRef>
+        </p:style>
+        <p:txBody>
+          <a:bodyPr rtlCol="0" anchor="ctr"/>
+          <a:lstStyle/>
+          <a:p>
+            <a:pPr algn="ctr"/>
+          </a:p>
+        </p:txBody>
+      </p:sp>
+      <p:sp>
+        <p:nvSpPr>
+          <p:cNvPr id="22" name="TextBox 21"/>
+          <p:cNvSpPr txBox="1"/>
+          <p:nvPr/>
+        </p:nvSpPr>
+        <p:spPr>
+          <a:xfrm>
+            <a:off x="868680" y="3611880"/>
+            <a:ext cx="10424160" cy="228600"/>
+          </a:xfrm>
+          <a:prstGeom prst="rect">
+            <a:avLst/>
+          </a:prstGeom>
+          <a:noFill/>
+        </p:spPr>
+        <p:txBody>
+          <a:bodyPr wrap="none">
+            <a:spAutoFit/>
+          </a:bodyPr>
+          <a:lstStyle/>
+          <a:p>
+            <a:pPr>
+              <a:defRPr sz="950" b="1">
+                <a:solidFill>
+                  <a:srgbClr val="F58220"/>
+                </a:solidFill>
+              </a:defRPr>
+            </a:pPr>
+            <a:r>
+              <a:t>4. CORE API &amp; SIMULATION ENGINE (backend FastAPI :8010)</a:t>
+            </a:r>
+          </a:p>
+        </p:txBody>
+      </p:sp>
+      <p:sp>
+        <p:nvSpPr>
+          <p:cNvPr id="23" name="Rounded Rectangle 22"/>
+          <p:cNvSpPr/>
+          <p:nvPr/>
+        </p:nvSpPr>
+        <p:spPr>
+          <a:xfrm>
+            <a:off x="914400" y="3886200"/>
+            <a:ext cx="1993392" cy="731520"/>
+          </a:xfrm>
+          <a:prstGeom prst="roundRect">
+            <a:avLst/>
+          </a:prstGeom>
+          <a:solidFill>
+            <a:srgbClr val="2A1B0A"/>
+          </a:solidFill>
+          <a:ln>
+            <a:solidFill>
+              <a:srgbClr val="7C2D12"/>
+            </a:solidFill>
+          </a:ln>
+        </p:spPr>
+        <p:style>
+          <a:lnRef idx="1">
+            <a:schemeClr val="accent1"/>
+          </a:lnRef>
+          <a:fillRef idx="3">
+            <a:schemeClr val="accent1"/>
+          </a:fillRef>
+          <a:effectRef idx="2">
+            <a:schemeClr val="accent1"/>
+          </a:effectRef>
+          <a:fontRef idx="minor">
+            <a:schemeClr val="lt1"/>
+          </a:fontRef>
+        </p:style>
+        <p:txBody>
+          <a:bodyPr rtlCol="0" anchor="ctr" wrap="square" tIns="54864"/>
+          <a:lstStyle/>
+          <a:p>
+            <a:pPr algn="ctr">
+              <a:defRPr sz="1050" b="1">
+                <a:solidFill>
+                  <a:srgbClr val="FFFFFF"/>
+                </a:solidFill>
+              </a:defRPr>
+            </a:pPr>
+            <a:r>
+              <a:t>🌊 SLOSH Surge Model</a:t>
+            </a:r>
+          </a:p>
+          <a:p>
+            <a:pPr>
+              <a:defRPr sz="850">
+                <a:solidFill>
+                  <a:srgbClr val="FED7AA"/>
+                </a:solidFill>
+              </a:defRPr>
+            </a:pPr>
+            <a:r>
+              <a:t>Hydrodynamic surge &amp; bathymetry</a:t>
+            </a:r>
+          </a:p>
+        </p:txBody>
+      </p:sp>
+      <p:sp>
+        <p:nvSpPr>
+          <p:cNvPr id="24" name="Rounded Rectangle 23"/>
+          <p:cNvSpPr/>
+          <p:nvPr/>
+        </p:nvSpPr>
+        <p:spPr>
+          <a:xfrm>
+            <a:off x="2999231" y="3886200"/>
+            <a:ext cx="1993392" cy="731520"/>
+          </a:xfrm>
+          <a:prstGeom prst="roundRect">
+            <a:avLst/>
+          </a:prstGeom>
+          <a:solidFill>
+            <a:srgbClr val="2A1B0A"/>
+          </a:solidFill>
+          <a:ln>
+            <a:solidFill>
+              <a:srgbClr val="7C2D12"/>
+            </a:solidFill>
+          </a:ln>
+        </p:spPr>
+        <p:style>
+          <a:lnRef idx="1">
+            <a:schemeClr val="accent1"/>
+          </a:lnRef>
+          <a:fillRef idx="3">
+            <a:schemeClr val="accent1"/>
+          </a:fillRef>
+          <a:effectRef idx="2">
+            <a:schemeClr val="accent1"/>
+          </a:effectRef>
+          <a:fontRef idx="minor">
+            <a:schemeClr val="lt1"/>
+          </a:fontRef>
+        </p:style>
+        <p:txBody>
+          <a:bodyPr rtlCol="0" anchor="ctr" wrap="square" tIns="54864"/>
+          <a:lstStyle/>
+          <a:p>
+            <a:pPr algn="ctr">
+              <a:defRPr sz="1050" b="1">
+                <a:solidFill>
+                  <a:srgbClr val="FFFFFF"/>
+                </a:solidFill>
+              </a:defRPr>
+            </a:pPr>
+            <a:r>
+              <a:t>💧 Compound Flood</a:t>
+            </a:r>
+          </a:p>
+          <a:p>
+            <a:pPr>
+              <a:defRPr sz="850">
+                <a:solidFill>
+                  <a:srgbClr val="FED7AA"/>
+                </a:solidFill>
+              </a:defRPr>
+            </a:pPr>
+            <a:r>
+              <a:t>River backflow &amp; compound runoff</a:t>
+            </a:r>
+          </a:p>
+        </p:txBody>
+      </p:sp>
+      <p:sp>
+        <p:nvSpPr>
+          <p:cNvPr id="25" name="Rounded Rectangle 24"/>
+          <p:cNvSpPr/>
+          <p:nvPr/>
+        </p:nvSpPr>
+        <p:spPr>
+          <a:xfrm>
+            <a:off x="5084062" y="3886200"/>
+            <a:ext cx="1993392" cy="731520"/>
+          </a:xfrm>
+          <a:prstGeom prst="roundRect">
+            <a:avLst/>
+          </a:prstGeom>
+          <a:solidFill>
+            <a:srgbClr val="2A1B0A"/>
+          </a:solidFill>
+          <a:ln>
+            <a:solidFill>
+              <a:srgbClr val="7C2D12"/>
+            </a:solidFill>
+          </a:ln>
+        </p:spPr>
+        <p:style>
+          <a:lnRef idx="1">
+            <a:schemeClr val="accent1"/>
+          </a:lnRef>
+          <a:fillRef idx="3">
+            <a:schemeClr val="accent1"/>
+          </a:fillRef>
+          <a:effectRef idx="2">
+            <a:schemeClr val="accent1"/>
+          </a:effectRef>
+          <a:fontRef idx="minor">
+            <a:schemeClr val="lt1"/>
+          </a:fontRef>
+        </p:style>
+        <p:txBody>
+          <a:bodyPr rtlCol="0" anchor="ctr" wrap="square" tIns="54864"/>
+          <a:lstStyle/>
+          <a:p>
+            <a:pPr algn="ctr">
+              <a:defRPr sz="1050" b="1">
+                <a:solidFill>
+                  <a:srgbClr val="FFFFFF"/>
+                </a:solidFill>
+              </a:defRPr>
+            </a:pPr>
+            <a:r>
+              <a:t>🕸️ NetworkX Graph</a:t>
+            </a:r>
+          </a:p>
+          <a:p>
+            <a:pPr>
+              <a:defRPr sz="850">
+                <a:solidFill>
+                  <a:srgbClr val="FED7AA"/>
+                </a:solidFill>
+              </a:defRPr>
+            </a:pPr>
+            <a:r>
+              <a:t>Dynamic road severance &amp; isolation</a:t>
+            </a:r>
+          </a:p>
+        </p:txBody>
+      </p:sp>
+      <p:sp>
+        <p:nvSpPr>
+          <p:cNvPr id="26" name="Rounded Rectangle 25"/>
+          <p:cNvSpPr/>
+          <p:nvPr/>
+        </p:nvSpPr>
+        <p:spPr>
+          <a:xfrm>
+            <a:off x="7168893" y="3886200"/>
+            <a:ext cx="1993392" cy="731520"/>
+          </a:xfrm>
+          <a:prstGeom prst="roundRect">
+            <a:avLst/>
+          </a:prstGeom>
+          <a:solidFill>
+            <a:srgbClr val="2A1B0A"/>
+          </a:solidFill>
+          <a:ln>
+            <a:solidFill>
+              <a:srgbClr val="7C2D12"/>
+            </a:solidFill>
+          </a:ln>
+        </p:spPr>
+        <p:style>
+          <a:lnRef idx="1">
+            <a:schemeClr val="accent1"/>
+          </a:lnRef>
+          <a:fillRef idx="3">
+            <a:schemeClr val="accent1"/>
+          </a:fillRef>
+          <a:effectRef idx="2">
+            <a:schemeClr val="accent1"/>
+          </a:effectRef>
+          <a:fontRef idx="minor">
+            <a:schemeClr val="lt1"/>
+          </a:fontRef>
+        </p:style>
+        <p:txBody>
+          <a:bodyPr rtlCol="0" anchor="ctr" wrap="square" tIns="54864"/>
+          <a:lstStyle/>
+          <a:p>
+            <a:pPr algn="ctr">
+              <a:defRPr sz="1050" b="1">
+                <a:solidFill>
+                  <a:srgbClr val="FFFFFF"/>
+                </a:solidFill>
+              </a:defRPr>
+            </a:pPr>
+            <a:r>
+              <a:t>💳 Parametric Escrow</a:t>
+            </a:r>
+          </a:p>
+          <a:p>
+            <a:pPr>
+              <a:defRPr sz="850">
+                <a:solidFill>
+                  <a:srgbClr val="FED7AA"/>
+                </a:solidFill>
+              </a:defRPr>
+            </a:pPr>
+            <a:r>
+              <a:t>T-24h smart contract escrow trigger</a:t>
+            </a:r>
+          </a:p>
+        </p:txBody>
+      </p:sp>
+      <p:sp>
+        <p:nvSpPr>
+          <p:cNvPr id="27" name="Rounded Rectangle 26"/>
+          <p:cNvSpPr/>
+          <p:nvPr/>
+        </p:nvSpPr>
+        <p:spPr>
+          <a:xfrm>
+            <a:off x="9253724" y="3886200"/>
+            <a:ext cx="1993392" cy="731520"/>
+          </a:xfrm>
+          <a:prstGeom prst="roundRect">
+            <a:avLst/>
+          </a:prstGeom>
+          <a:solidFill>
+            <a:srgbClr val="2A1B0A"/>
+          </a:solidFill>
+          <a:ln>
+            <a:solidFill>
+              <a:srgbClr val="7C2D12"/>
+            </a:solidFill>
+          </a:ln>
+        </p:spPr>
+        <p:style>
+          <a:lnRef idx="1">
+            <a:schemeClr val="accent1"/>
+          </a:lnRef>
+          <a:fillRef idx="3">
+            <a:schemeClr val="accent1"/>
+          </a:fillRef>
+          <a:effectRef idx="2">
+            <a:schemeClr val="accent1"/>
+          </a:effectRef>
+          <a:fontRef idx="minor">
+            <a:schemeClr val="lt1"/>
+          </a:fontRef>
+        </p:style>
+        <p:txBody>
+          <a:bodyPr rtlCol="0" anchor="ctr" wrap="square" tIns="54864"/>
+          <a:lstStyle/>
+          <a:p>
+            <a:pPr algn="ctr">
+              <a:defRPr sz="1050" b="1">
+                <a:solidFill>
+                  <a:srgbClr val="FFFFFF"/>
+                </a:solidFill>
+              </a:defRPr>
+            </a:pPr>
+            <a:r>
+              <a:t>🧠 Gemini Flash AI</a:t>
+            </a:r>
+          </a:p>
+          <a:p>
+            <a:pPr>
+              <a:defRPr sz="850">
+                <a:solidFill>
+                  <a:srgbClr val="FED7AA"/>
+                </a:solidFill>
+              </a:defRPr>
+            </a:pPr>
+            <a:r>
+              <a:t>Multimodal reasoning &amp; 22 Indic SOPs</a:t>
+            </a:r>
+          </a:p>
+        </p:txBody>
+      </p:sp>
+      <p:sp>
+        <p:nvSpPr>
+          <p:cNvPr id="28" name="Rounded Rectangle 27"/>
+          <p:cNvSpPr/>
+          <p:nvPr/>
+        </p:nvSpPr>
+        <p:spPr>
+          <a:xfrm>
+            <a:off x="731520" y="4892040"/>
+            <a:ext cx="10698480" cy="1097280"/>
+          </a:xfrm>
+          <a:prstGeom prst="roundRect">
+            <a:avLst/>
+          </a:prstGeom>
+          <a:solidFill>
+            <a:srgbClr val="0F213C"/>
+          </a:solidFill>
+          <a:ln>
+            <a:solidFill>
+              <a:srgbClr val="00D1B2"/>
+            </a:solidFill>
+          </a:ln>
+        </p:spPr>
+        <p:style>
+          <a:lnRef idx="1">
+            <a:schemeClr val="accent1"/>
+          </a:lnRef>
+          <a:fillRef idx="3">
+            <a:schemeClr val="accent1"/>
+          </a:fillRef>
+          <a:effectRef idx="2">
+            <a:schemeClr val="accent1"/>
+          </a:effectRef>
+          <a:fontRef idx="minor">
+            <a:schemeClr val="lt1"/>
+          </a:fontRef>
+        </p:style>
+        <p:txBody>
+          <a:bodyPr rtlCol="0" anchor="ctr"/>
+          <a:lstStyle/>
+          <a:p>
+            <a:pPr algn="ctr"/>
+          </a:p>
+        </p:txBody>
+      </p:sp>
+      <p:sp>
+        <p:nvSpPr>
+          <p:cNvPr id="29" name="TextBox 28"/>
+          <p:cNvSpPr txBox="1"/>
+          <p:nvPr/>
+        </p:nvSpPr>
+        <p:spPr>
+          <a:xfrm>
+            <a:off x="868680" y="4937760"/>
+            <a:ext cx="10424160" cy="228600"/>
+          </a:xfrm>
+          <a:prstGeom prst="rect">
+            <a:avLst/>
+          </a:prstGeom>
+          <a:noFill/>
+        </p:spPr>
+        <p:txBody>
+          <a:bodyPr wrap="none">
+            <a:spAutoFit/>
+          </a:bodyPr>
+          <a:lstStyle/>
+          <a:p>
+            <a:pPr>
+              <a:defRPr sz="950" b="1">
+                <a:solidFill>
+                  <a:srgbClr val="00D1B2"/>
+                </a:solidFill>
+              </a:defRPr>
+            </a:pPr>
+            <a:r>
+              <a:t>5. PRESENTATION LAYER (frontend React 18 + TypeScript + Vite :5174)</a:t>
+            </a:r>
+          </a:p>
+        </p:txBody>
+      </p:sp>
+      <p:sp>
+        <p:nvSpPr>
+          <p:cNvPr id="30" name="Rounded Rectangle 29"/>
+          <p:cNvSpPr/>
+          <p:nvPr/>
+        </p:nvSpPr>
+        <p:spPr>
+          <a:xfrm>
+            <a:off x="914400" y="5212080"/>
+            <a:ext cx="1993392" cy="658368"/>
+          </a:xfrm>
+          <a:prstGeom prst="roundRect">
+            <a:avLst/>
+          </a:prstGeom>
+          <a:solidFill>
+            <a:srgbClr val="042F2E"/>
+          </a:solidFill>
+          <a:ln>
+            <a:solidFill>
+              <a:srgbClr val="115E59"/>
+            </a:solidFill>
+          </a:ln>
+        </p:spPr>
+        <p:style>
+          <a:lnRef idx="1">
+            <a:schemeClr val="accent1"/>
+          </a:lnRef>
+          <a:fillRef idx="3">
+            <a:schemeClr val="accent1"/>
+          </a:fillRef>
+          <a:effectRef idx="2">
+            <a:schemeClr val="accent1"/>
+          </a:effectRef>
+          <a:fontRef idx="minor">
+            <a:schemeClr val="lt1"/>
+          </a:fontRef>
+        </p:style>
+        <p:txBody>
+          <a:bodyPr rtlCol="0" anchor="ctr" wrap="square" tIns="54864"/>
+          <a:lstStyle/>
+          <a:p>
+            <a:pPr algn="ctr">
+              <a:defRPr sz="1000" b="1">
+                <a:solidFill>
+                  <a:srgbClr val="FFFFFF"/>
+                </a:solidFill>
+              </a:defRPr>
+            </a:pPr>
+            <a:r>
+              <a:t>🏛️ War Room Console</a:t>
+            </a:r>
+          </a:p>
+          <a:p>
+            <a:pPr>
+              <a:defRPr sz="850">
+                <a:solidFill>
+                  <a:srgbClr val="99F6E4"/>
+                </a:solidFill>
+              </a:defRPr>
+            </a:pPr>
+            <a:r>
+              <a:t>National &amp; State ops command</a:t>
+            </a:r>
+          </a:p>
+        </p:txBody>
+      </p:sp>
+      <p:sp>
+        <p:nvSpPr>
+          <p:cNvPr id="31" name="Rounded Rectangle 30"/>
+          <p:cNvSpPr/>
+          <p:nvPr/>
+        </p:nvSpPr>
+        <p:spPr>
+          <a:xfrm>
+            <a:off x="2999231" y="5212080"/>
+            <a:ext cx="1993392" cy="658368"/>
+          </a:xfrm>
+          <a:prstGeom prst="roundRect">
+            <a:avLst/>
+          </a:prstGeom>
+          <a:solidFill>
+            <a:srgbClr val="042F2E"/>
+          </a:solidFill>
+          <a:ln>
+            <a:solidFill>
+              <a:srgbClr val="115E59"/>
+            </a:solidFill>
+          </a:ln>
+        </p:spPr>
+        <p:style>
+          <a:lnRef idx="1">
+            <a:schemeClr val="accent1"/>
+          </a:lnRef>
+          <a:fillRef idx="3">
+            <a:schemeClr val="accent1"/>
+          </a:fillRef>
+          <a:effectRef idx="2">
+            <a:schemeClr val="accent1"/>
+          </a:effectRef>
+          <a:fontRef idx="minor">
+            <a:schemeClr val="lt1"/>
+          </a:fontRef>
+        </p:style>
+        <p:txBody>
+          <a:bodyPr rtlCol="0" anchor="ctr" wrap="square" tIns="54864"/>
+          <a:lstStyle/>
+          <a:p>
+            <a:pPr algn="ctr">
+              <a:defRPr sz="1000" b="1">
+                <a:solidFill>
+                  <a:srgbClr val="FFFFFF"/>
+                </a:solidFill>
+              </a:defRPr>
+            </a:pPr>
+            <a:r>
+              <a:t>🗺️ Leaflet GIS 3D</a:t>
+            </a:r>
+          </a:p>
+          <a:p>
+            <a:pPr>
+              <a:defRPr sz="850">
+                <a:solidFill>
+                  <a:srgbClr val="99F6E4"/>
+                </a:solidFill>
+              </a:defRPr>
+            </a:pPr>
+            <a:r>
+              <a:t>Inundation &amp; severed lifelines</a:t>
+            </a:r>
+          </a:p>
+        </p:txBody>
+      </p:sp>
+      <p:sp>
+        <p:nvSpPr>
+          <p:cNvPr id="32" name="Rounded Rectangle 31"/>
+          <p:cNvSpPr/>
+          <p:nvPr/>
+        </p:nvSpPr>
+        <p:spPr>
+          <a:xfrm>
+            <a:off x="5084062" y="5212080"/>
+            <a:ext cx="1993392" cy="658368"/>
+          </a:xfrm>
+          <a:prstGeom prst="roundRect">
+            <a:avLst/>
+          </a:prstGeom>
+          <a:solidFill>
+            <a:srgbClr val="042F2E"/>
+          </a:solidFill>
+          <a:ln>
+            <a:solidFill>
+              <a:srgbClr val="115E59"/>
+            </a:solidFill>
+          </a:ln>
+        </p:spPr>
+        <p:style>
+          <a:lnRef idx="1">
+            <a:schemeClr val="accent1"/>
+          </a:lnRef>
+          <a:fillRef idx="3">
+            <a:schemeClr val="accent1"/>
+          </a:fillRef>
+          <a:effectRef idx="2">
+            <a:schemeClr val="accent1"/>
+          </a:effectRef>
+          <a:fontRef idx="minor">
+            <a:schemeClr val="lt1"/>
+          </a:fontRef>
+        </p:style>
+        <p:txBody>
+          <a:bodyPr rtlCol="0" anchor="ctr" wrap="square" tIns="54864"/>
+          <a:lstStyle/>
+          <a:p>
+            <a:pPr algn="ctr">
+              <a:defRPr sz="1000" b="1">
+                <a:solidFill>
+                  <a:srgbClr val="FFFFFF"/>
+                </a:solidFill>
+              </a:defRPr>
+            </a:pPr>
+            <a:r>
+              <a:t>⏱️ Temporal Scrubber</a:t>
+            </a:r>
+          </a:p>
+          <a:p>
+            <a:pPr>
+              <a:defRPr sz="850">
+                <a:solidFill>
+                  <a:srgbClr val="99F6E4"/>
+                </a:solidFill>
+              </a:defRPr>
+            </a:pPr>
+            <a:r>
+              <a:t>T-72h to Landfall playhead</a:t>
+            </a:r>
+          </a:p>
+        </p:txBody>
+      </p:sp>
+      <p:sp>
+        <p:nvSpPr>
+          <p:cNvPr id="33" name="Rounded Rectangle 32"/>
+          <p:cNvSpPr/>
+          <p:nvPr/>
+        </p:nvSpPr>
+        <p:spPr>
+          <a:xfrm>
+            <a:off x="7168893" y="5212080"/>
+            <a:ext cx="1993392" cy="658368"/>
+          </a:xfrm>
+          <a:prstGeom prst="roundRect">
+            <a:avLst/>
+          </a:prstGeom>
+          <a:solidFill>
+            <a:srgbClr val="042F2E"/>
+          </a:solidFill>
+          <a:ln>
+            <a:solidFill>
+              <a:srgbClr val="115E59"/>
+            </a:solidFill>
+          </a:ln>
+        </p:spPr>
+        <p:style>
+          <a:lnRef idx="1">
+            <a:schemeClr val="accent1"/>
+          </a:lnRef>
+          <a:fillRef idx="3">
+            <a:schemeClr val="accent1"/>
+          </a:fillRef>
+          <a:effectRef idx="2">
+            <a:schemeClr val="accent1"/>
+          </a:effectRef>
+          <a:fontRef idx="minor">
+            <a:schemeClr val="lt1"/>
+          </a:fontRef>
+        </p:style>
+        <p:txBody>
+          <a:bodyPr rtlCol="0" anchor="ctr" wrap="square" tIns="54864"/>
+          <a:lstStyle/>
+          <a:p>
+            <a:pPr algn="ctr">
+              <a:defRPr sz="1000" b="1">
+                <a:solidFill>
+                  <a:srgbClr val="FFFFFF"/>
+                </a:solidFill>
+              </a:defRPr>
+            </a:pPr>
+            <a:r>
+              <a:t>📢 Indic Audio Drawer</a:t>
+            </a:r>
+          </a:p>
+          <a:p>
+            <a:pPr>
+              <a:defRPr sz="850">
+                <a:solidFill>
+                  <a:srgbClr val="99F6E4"/>
+                </a:solidFill>
+              </a:defRPr>
+            </a:pPr>
+            <a:r>
+              <a:t>22 Official languages speech</a:t>
+            </a:r>
+          </a:p>
+        </p:txBody>
+      </p:sp>
+      <p:sp>
+        <p:nvSpPr>
+          <p:cNvPr id="34" name="Rounded Rectangle 33"/>
+          <p:cNvSpPr/>
+          <p:nvPr/>
+        </p:nvSpPr>
+        <p:spPr>
+          <a:xfrm>
+            <a:off x="9253724" y="5212080"/>
+            <a:ext cx="1993392" cy="658368"/>
+          </a:xfrm>
+          <a:prstGeom prst="roundRect">
+            <a:avLst/>
+          </a:prstGeom>
+          <a:solidFill>
+            <a:srgbClr val="042F2E"/>
+          </a:solidFill>
+          <a:ln>
+            <a:solidFill>
+              <a:srgbClr val="115E59"/>
+            </a:solidFill>
+          </a:ln>
+        </p:spPr>
+        <p:style>
+          <a:lnRef idx="1">
+            <a:schemeClr val="accent1"/>
+          </a:lnRef>
+          <a:fillRef idx="3">
+            <a:schemeClr val="accent1"/>
+          </a:fillRef>
+          <a:effectRef idx="2">
+            <a:schemeClr val="accent1"/>
+          </a:effectRef>
+          <a:fontRef idx="minor">
+            <a:schemeClr val="lt1"/>
+          </a:fontRef>
+        </p:style>
+        <p:txBody>
+          <a:bodyPr rtlCol="0" anchor="ctr" wrap="square" tIns="54864"/>
+          <a:lstStyle/>
+          <a:p>
+            <a:pPr algn="ctr">
+              <a:defRPr sz="1000" b="1">
+                <a:solidFill>
+                  <a:srgbClr val="FFFFFF"/>
+                </a:solidFill>
+              </a:defRPr>
+            </a:pPr>
+            <a:r>
+              <a:t>🪙 Parametric Terminal</a:t>
+            </a:r>
+          </a:p>
+          <a:p>
+            <a:pPr>
+              <a:defRPr sz="850">
+                <a:solidFill>
+                  <a:srgbClr val="99F6E4"/>
+                </a:solidFill>
+              </a:defRPr>
+            </a:pPr>
+            <a:r>
+              <a:t>Pre-landfall liquidity release</a:t>
+            </a:r>
+          </a:p>
+        </p:txBody>
+      </p:sp>
+      <p:sp>
+        <p:nvSpPr>
+          <p:cNvPr id="35" name="Rounded Rectangle 34"/>
+          <p:cNvSpPr/>
+          <p:nvPr/>
+        </p:nvSpPr>
+        <p:spPr>
+          <a:xfrm>
+            <a:off x="731520" y="6080760"/>
+            <a:ext cx="10698480" cy="502920"/>
           </a:xfrm>
           <a:prstGeom prst="roundRect">
             <a:avLst/>
@@ -4591,18 +6269,18 @@
           </a:fontRef>
         </p:style>
         <p:txBody>
-          <a:bodyPr rtlCol="0" anchor="ctr" wrap="square"/>
+          <a:bodyPr rtlCol="0" anchor="ctr"/>
           <a:lstStyle/>
           <a:p>
             <a:pPr algn="ctr">
-              <a:defRPr sz="1150" b="1">
+              <a:defRPr sz="1100" b="1">
                 <a:solidFill>
                   <a:srgbClr val="00D1B2"/>
                 </a:solidFill>
               </a:defRPr>
             </a:pPr>
             <a:r>
-              <a:t>⚡ Architectural Flow: External Feeds &amp; GEE ➔ Async Ingestion Engine (:8001) ➔ PostGIS / Redis ➔ FastAPI Engine (:8010) ➔ SLOSH / NetworkX / Gemini Flash ➔ War Room &amp; 22 Indic Audio (:5174)</a:t>
+              <a:t>⚡ Real-Time Pipeline: Feeds &amp; GEE ➔ Ingestion (:8001) ➔ PostGIS / Redis ➔ FastAPI Engine (:8010) ➔ SLOSH &amp; Gemini Flash ➔ War Room (:5174)</a:t>
             </a:r>
           </a:p>
         </p:txBody>
@@ -4641,7 +6319,7 @@
         </p:nvSpPr>
         <p:spPr>
           <a:xfrm>
-            <a:off x="731520" y="457200"/>
+            <a:off x="731520" y="365760"/>
             <a:ext cx="73152" cy="411480"/>
           </a:xfrm>
           <a:prstGeom prst="rect">
@@ -4684,7 +6362,7 @@
         </p:nvSpPr>
         <p:spPr>
           <a:xfrm>
-            <a:off x="914400" y="411480"/>
+            <a:off x="914400" y="320040"/>
             <a:ext cx="10515600" cy="502920"/>
           </a:xfrm>
           <a:prstGeom prst="rect">
@@ -4699,7 +6377,7 @@
           <a:lstStyle/>
           <a:p>
             <a:pPr>
-              <a:defRPr sz="2400" b="1">
+              <a:defRPr sz="2200" b="1">
                 <a:solidFill>
                   <a:srgbClr val="0F172A"/>
                 </a:solidFill>
@@ -5489,7 +7167,7 @@
         </p:nvSpPr>
         <p:spPr>
           <a:xfrm>
-            <a:off x="731520" y="457200"/>
+            <a:off x="731520" y="365760"/>
             <a:ext cx="73152" cy="411480"/>
           </a:xfrm>
           <a:prstGeom prst="rect">
@@ -5532,7 +7210,7 @@
         </p:nvSpPr>
         <p:spPr>
           <a:xfrm>
-            <a:off x="914400" y="411480"/>
+            <a:off x="914400" y="320040"/>
             <a:ext cx="10515600" cy="502920"/>
           </a:xfrm>
           <a:prstGeom prst="rect">
@@ -5547,7 +7225,7 @@
           <a:lstStyle/>
           <a:p>
             <a:pPr>
-              <a:defRPr sz="2400" b="1">
+              <a:defRPr sz="2200" b="1">
                 <a:solidFill>
                   <a:srgbClr val="0F172A"/>
                 </a:solidFill>
@@ -5811,7 +7489,7 @@
         </p:nvSpPr>
         <p:spPr>
           <a:xfrm>
-            <a:off x="731520" y="457200"/>
+            <a:off x="731520" y="365760"/>
             <a:ext cx="73152" cy="411480"/>
           </a:xfrm>
           <a:prstGeom prst="rect">
@@ -5854,7 +7532,7 @@
         </p:nvSpPr>
         <p:spPr>
           <a:xfrm>
-            <a:off x="914400" y="411480"/>
+            <a:off x="914400" y="320040"/>
             <a:ext cx="10515600" cy="502920"/>
           </a:xfrm>
           <a:prstGeom prst="rect">
@@ -5869,7 +7547,7 @@
           <a:lstStyle/>
           <a:p>
             <a:pPr>
-              <a:defRPr sz="2400" b="1">
+              <a:defRPr sz="2200" b="1">
                 <a:solidFill>
                   <a:srgbClr val="0F172A"/>
                 </a:solidFill>
@@ -6383,7 +8061,7 @@
         </p:nvSpPr>
         <p:spPr>
           <a:xfrm>
-            <a:off x="731520" y="457200"/>
+            <a:off x="731520" y="365760"/>
             <a:ext cx="73152" cy="411480"/>
           </a:xfrm>
           <a:prstGeom prst="rect">
@@ -6426,7 +8104,7 @@
         </p:nvSpPr>
         <p:spPr>
           <a:xfrm>
-            <a:off x="914400" y="411480"/>
+            <a:off x="914400" y="320040"/>
             <a:ext cx="10515600" cy="502920"/>
           </a:xfrm>
           <a:prstGeom prst="rect">
@@ -6441,7 +8119,7 @@
           <a:lstStyle/>
           <a:p>
             <a:pPr>
-              <a:defRPr sz="2400" b="1">
+              <a:defRPr sz="2200" b="1">
                 <a:solidFill>
                   <a:srgbClr val="0F172A"/>
                 </a:solidFill>
@@ -6676,7 +8354,7 @@
         </p:nvSpPr>
         <p:spPr>
           <a:xfrm>
-            <a:off x="731520" y="457200"/>
+            <a:off x="731520" y="365760"/>
             <a:ext cx="73152" cy="411480"/>
           </a:xfrm>
           <a:prstGeom prst="rect">
@@ -6719,7 +8397,7 @@
         </p:nvSpPr>
         <p:spPr>
           <a:xfrm>
-            <a:off x="914400" y="411480"/>
+            <a:off x="914400" y="320040"/>
             <a:ext cx="10515600" cy="502920"/>
           </a:xfrm>
           <a:prstGeom prst="rect">
@@ -6734,7 +8412,7 @@
           <a:lstStyle/>
           <a:p>
             <a:pPr>
-              <a:defRPr sz="2400" b="1">
+              <a:defRPr sz="2200" b="1">
                 <a:solidFill>
                   <a:srgbClr val="0F172A"/>
                 </a:solidFill>
@@ -6960,7 +8638,7 @@
         </p:nvSpPr>
         <p:spPr>
           <a:xfrm>
-            <a:off x="731520" y="457200"/>
+            <a:off x="731520" y="365760"/>
             <a:ext cx="73152" cy="411480"/>
           </a:xfrm>
           <a:prstGeom prst="rect">
@@ -7003,7 +8681,7 @@
         </p:nvSpPr>
         <p:spPr>
           <a:xfrm>
-            <a:off x="914400" y="411480"/>
+            <a:off x="914400" y="320040"/>
             <a:ext cx="10515600" cy="502920"/>
           </a:xfrm>
           <a:prstGeom prst="rect">
@@ -7018,7 +8696,7 @@
           <a:lstStyle/>
           <a:p>
             <a:pPr>
-              <a:defRPr sz="2400" b="1">
+              <a:defRPr sz="2200" b="1">
                 <a:solidFill>
                   <a:srgbClr val="0F172A"/>
                 </a:solidFill>
@@ -7253,7 +8931,7 @@
         </p:nvSpPr>
         <p:spPr>
           <a:xfrm>
-            <a:off x="731520" y="457200"/>
+            <a:off x="731520" y="365760"/>
             <a:ext cx="73152" cy="411480"/>
           </a:xfrm>
           <a:prstGeom prst="rect">
@@ -7296,7 +8974,7 @@
         </p:nvSpPr>
         <p:spPr>
           <a:xfrm>
-            <a:off x="914400" y="411480"/>
+            <a:off x="914400" y="320040"/>
             <a:ext cx="10515600" cy="502920"/>
           </a:xfrm>
           <a:prstGeom prst="rect">
@@ -7311,7 +8989,7 @@
           <a:lstStyle/>
           <a:p>
             <a:pPr>
-              <a:defRPr sz="2400" b="1">
+              <a:defRPr sz="2200" b="1">
                 <a:solidFill>
                   <a:srgbClr val="0F172A"/>
                 </a:solidFill>
@@ -7546,7 +9224,7 @@
         </p:nvSpPr>
         <p:spPr>
           <a:xfrm>
-            <a:off x="731520" y="457200"/>
+            <a:off x="731520" y="365760"/>
             <a:ext cx="73152" cy="411480"/>
           </a:xfrm>
           <a:prstGeom prst="rect">
@@ -7589,7 +9267,7 @@
         </p:nvSpPr>
         <p:spPr>
           <a:xfrm>
-            <a:off x="914400" y="411480"/>
+            <a:off x="914400" y="320040"/>
             <a:ext cx="10515600" cy="502920"/>
           </a:xfrm>
           <a:prstGeom prst="rect">
@@ -7604,7 +9282,7 @@
           <a:lstStyle/>
           <a:p>
             <a:pPr>
-              <a:defRPr sz="2400" b="1">
+              <a:defRPr sz="2200" b="1">
                 <a:solidFill>
                   <a:srgbClr val="0F172A"/>
                 </a:solidFill>

</xml_diff>